<commit_message>
Receipts slide: final score + both lines + per-side miss distances
Each row now shows our line vs the closing line and how far each was
from the final margin (machine closer 2, market closer 3 - both off by
exactly 70.0 points across the five games). Lean verdicts fold into the
footer band.

Co-Authored-By: Claude Fable 5 <noreply@anthropic.com>
</commit_message>
<xml_diff>
--- a/decks/2026_Week1_Episode2.pptx
+++ b/decks/2026_Week1_Episode2.pptx
@@ -10163,7 +10163,7 @@
                 </a:solidFill>
                 <a:latin typeface="Arial"/>
               </a:rPr>
-              <a:t>Frozen at kickoff · graded vs finals and the last pre-kick pull (Sat 10:16 ET) · leans graded vs first-seen lines</a:t>
+              <a:t>Our call frozen at kickoff · closing line = last pre-kick pull (Sat 10:16 ET) · “off by” = miss vs the final margin</a:t>
             </a:r>
           </a:p>
         </p:txBody>
@@ -10325,7 +10325,7 @@
                 </a:solidFill>
                 <a:latin typeface="Arial"/>
               </a:rPr>
-              <a:t>called TCU 25–23 · final UNC 15–10</a:t>
+              <a:t>we called TCU 25–23 · FINAL UNC 15–10</a:t>
             </a:r>
           </a:p>
         </p:txBody>
@@ -10338,8 +10338,8 @@
         </p:nvSpPr>
         <p:spPr>
           <a:xfrm>
-            <a:off x="6949440" y="1517904"/>
-            <a:ext cx="4160520" cy="274320"/>
+            <a:off x="6720840" y="1517904"/>
+            <a:ext cx="4389120" cy="274320"/>
           </a:xfrm>
           <a:prstGeom prst="rect">
             <a:avLst/>
@@ -10360,7 +10360,7 @@
                 </a:solidFill>
                 <a:latin typeface="Arial"/>
               </a:rPr>
-              <a:t>machine TCU –1.5 · close –7.5 · actual UNC by 5</a:t>
+              <a:t>our line TCU –1.5 · closing TCU –7.5</a:t>
             </a:r>
           </a:p>
         </p:txBody>
@@ -10373,29 +10373,29 @@
         </p:nvSpPr>
         <p:spPr>
           <a:xfrm>
-            <a:off x="6949440" y="1819656"/>
-            <a:ext cx="4160520" cy="274320"/>
-          </a:xfrm>
-          <a:prstGeom prst="rect">
-            <a:avLst/>
-          </a:prstGeom>
-          <a:noFill/>
-        </p:spPr>
-        <p:txBody>
-          <a:bodyPr wrap="square" lIns="0" rIns="0" tIns="0" bIns="0">
-            <a:spAutoFit/>
-          </a:bodyPr>
-          <a:lstStyle/>
-          <a:p>
-            <a:pPr algn="l"/>
-            <a:r>
-              <a:rPr sz="1050" b="1" i="0">
+            <a:off x="6720840" y="1819656"/>
+            <a:ext cx="4389120" cy="274320"/>
+          </a:xfrm>
+          <a:prstGeom prst="rect">
+            <a:avLst/>
+          </a:prstGeom>
+          <a:noFill/>
+        </p:spPr>
+        <p:txBody>
+          <a:bodyPr wrap="square" lIns="0" rIns="0" tIns="0" bIns="0">
+            <a:spAutoFit/>
+          </a:bodyPr>
+          <a:lstStyle/>
+          <a:p>
+            <a:pPr algn="l"/>
+            <a:r>
+              <a:rPr sz="1000" b="1" i="0">
                 <a:solidFill>
                   <a:srgbClr val="F47321"/>
                 </a:solidFill>
                 <a:latin typeface="Arial"/>
               </a:rPr>
-              <a:t>LEAN CASHED — UNC +6.5 won OUTRIGHT</a:t>
+              <a:t>machine off by 6.5 · market off by 12.5 — machine closer</a:t>
             </a:r>
           </a:p>
         </p:txBody>
@@ -10557,7 +10557,7 @@
                 </a:solidFill>
                 <a:latin typeface="Arial"/>
               </a:rPr>
-              <a:t>called UVA 30–23 · final UVA 34–8</a:t>
+              <a:t>we called UVA 30–23 · FINAL UVA 34–8</a:t>
             </a:r>
           </a:p>
         </p:txBody>
@@ -10570,8 +10570,8 @@
         </p:nvSpPr>
         <p:spPr>
           <a:xfrm>
-            <a:off x="6949440" y="2377440"/>
-            <a:ext cx="4160520" cy="274320"/>
+            <a:off x="6720840" y="2377440"/>
+            <a:ext cx="4389120" cy="274320"/>
           </a:xfrm>
           <a:prstGeom prst="rect">
             <a:avLst/>
@@ -10592,7 +10592,7 @@
                 </a:solidFill>
                 <a:latin typeface="Arial"/>
               </a:rPr>
-              <a:t>machine UVA –6.5 · close –4 · actual UVA by 26</a:t>
+              <a:t>our line UVA –6.5 · closing UVA –4</a:t>
             </a:r>
           </a:p>
         </p:txBody>
@@ -10605,29 +10605,29 @@
         </p:nvSpPr>
         <p:spPr>
           <a:xfrm>
-            <a:off x="6949440" y="2679192"/>
-            <a:ext cx="4160520" cy="274320"/>
-          </a:xfrm>
-          <a:prstGeom prst="rect">
-            <a:avLst/>
-          </a:prstGeom>
-          <a:noFill/>
-        </p:spPr>
-        <p:txBody>
-          <a:bodyPr wrap="square" lIns="0" rIns="0" tIns="0" bIns="0">
-            <a:spAutoFit/>
-          </a:bodyPr>
-          <a:lstStyle/>
-          <a:p>
-            <a:pPr algn="l"/>
-            <a:r>
-              <a:rPr sz="1050" b="1" i="0">
-                <a:solidFill>
-                  <a:srgbClr val="5C6B7E"/>
-                </a:solidFill>
-                <a:latin typeface="Arial"/>
-              </a:rPr>
-              <a:t>no play — right to pass</a:t>
+            <a:off x="6720840" y="2679192"/>
+            <a:ext cx="4389120" cy="274320"/>
+          </a:xfrm>
+          <a:prstGeom prst="rect">
+            <a:avLst/>
+          </a:prstGeom>
+          <a:noFill/>
+        </p:spPr>
+        <p:txBody>
+          <a:bodyPr wrap="square" lIns="0" rIns="0" tIns="0" bIns="0">
+            <a:spAutoFit/>
+          </a:bodyPr>
+          <a:lstStyle/>
+          <a:p>
+            <a:pPr algn="l"/>
+            <a:r>
+              <a:rPr sz="1000" b="1" i="0">
+                <a:solidFill>
+                  <a:srgbClr val="F47321"/>
+                </a:solidFill>
+                <a:latin typeface="Arial"/>
+              </a:rPr>
+              <a:t>machine off by 19.5 · market off by 22 — machine closer</a:t>
             </a:r>
           </a:p>
         </p:txBody>
@@ -10789,7 +10789,7 @@
                 </a:solidFill>
                 <a:latin typeface="Arial"/>
               </a:rPr>
-              <a:t>called NDSU 25–22 · final NDSU 33–7</a:t>
+              <a:t>we called NDSU 25–22 · FINAL NDSU 33–7</a:t>
             </a:r>
           </a:p>
         </p:txBody>
@@ -10802,8 +10802,8 @@
         </p:nvSpPr>
         <p:spPr>
           <a:xfrm>
-            <a:off x="6949440" y="3236976"/>
-            <a:ext cx="4160520" cy="274320"/>
+            <a:off x="6720840" y="3236976"/>
+            <a:ext cx="4389120" cy="274320"/>
           </a:xfrm>
           <a:prstGeom prst="rect">
             <a:avLst/>
@@ -10824,7 +10824,7 @@
                 </a:solidFill>
                 <a:latin typeface="Arial"/>
               </a:rPr>
-              <a:t>machine NDSU –2.5 · close –6.5 · actual NDSU by 26</a:t>
+              <a:t>our line NDSU –2.5 · closing NDSU –6.5</a:t>
             </a:r>
           </a:p>
         </p:txBody>
@@ -10837,29 +10837,29 @@
         </p:nvSpPr>
         <p:spPr>
           <a:xfrm>
-            <a:off x="6949440" y="3538728"/>
-            <a:ext cx="4160520" cy="274320"/>
-          </a:xfrm>
-          <a:prstGeom prst="rect">
-            <a:avLst/>
-          </a:prstGeom>
-          <a:noFill/>
-        </p:spPr>
-        <p:txBody>
-          <a:bodyPr wrap="square" lIns="0" rIns="0" tIns="0" bIns="0">
-            <a:spAutoFit/>
-          </a:bodyPr>
-          <a:lstStyle/>
-          <a:p>
-            <a:pPr algn="l"/>
-            <a:r>
-              <a:rPr sz="1050" b="1" i="0">
+            <a:off x="6720840" y="3538728"/>
+            <a:ext cx="4389120" cy="274320"/>
+          </a:xfrm>
+          <a:prstGeom prst="rect">
+            <a:avLst/>
+          </a:prstGeom>
+          <a:noFill/>
+        </p:spPr>
+        <p:txBody>
+          <a:bodyPr wrap="square" lIns="0" rIns="0" tIns="0" bIns="0">
+            <a:spAutoFit/>
+          </a:bodyPr>
+          <a:lstStyle/>
+          <a:p>
+            <a:pPr algn="l"/>
+            <a:r>
+              <a:rPr sz="1000" b="1" i="0">
                 <a:solidFill>
                   <a:srgbClr val="B5121B"/>
                 </a:solidFill>
                 <a:latin typeface="Arial"/>
               </a:rPr>
-              <a:t>JSU lean LOST by 19 vs the number</a:t>
+              <a:t>machine off by 23.5 · market off by 19.5 — market closer</a:t>
             </a:r>
           </a:p>
         </p:txBody>
@@ -11021,7 +11021,7 @@
                 </a:solidFill>
                 <a:latin typeface="Arial"/>
               </a:rPr>
-              <a:t>called Stanford 26–24 · final Stanford 37–27</a:t>
+              <a:t>we called Stanford 26–24 · FINAL Stanford 37–27</a:t>
             </a:r>
           </a:p>
         </p:txBody>
@@ -11034,8 +11034,8 @@
         </p:nvSpPr>
         <p:spPr>
           <a:xfrm>
-            <a:off x="6949440" y="4096512"/>
-            <a:ext cx="4160520" cy="274320"/>
+            <a:off x="6720840" y="4096512"/>
+            <a:ext cx="4389120" cy="274320"/>
           </a:xfrm>
           <a:prstGeom prst="rect">
             <a:avLst/>
@@ -11056,7 +11056,7 @@
                 </a:solidFill>
                 <a:latin typeface="Arial"/>
               </a:rPr>
-              <a:t>machine STAN –1.5 · close –4 · actual STAN by 10</a:t>
+              <a:t>our line Stanford –1.5 · closing Stanford –4</a:t>
             </a:r>
           </a:p>
         </p:txBody>
@@ -11069,29 +11069,29 @@
         </p:nvSpPr>
         <p:spPr>
           <a:xfrm>
-            <a:off x="6949440" y="4398264"/>
-            <a:ext cx="4160520" cy="274320"/>
-          </a:xfrm>
-          <a:prstGeom prst="rect">
-            <a:avLst/>
-          </a:prstGeom>
-          <a:noFill/>
-        </p:spPr>
-        <p:txBody>
-          <a:bodyPr wrap="square" lIns="0" rIns="0" tIns="0" bIns="0">
-            <a:spAutoFit/>
-          </a:bodyPr>
-          <a:lstStyle/>
-          <a:p>
-            <a:pPr algn="l"/>
-            <a:r>
-              <a:rPr sz="1050" b="1" i="0">
+            <a:off x="6720840" y="4398264"/>
+            <a:ext cx="4389120" cy="274320"/>
+          </a:xfrm>
+          <a:prstGeom prst="rect">
+            <a:avLst/>
+          </a:prstGeom>
+          <a:noFill/>
+        </p:spPr>
+        <p:txBody>
+          <a:bodyPr wrap="square" lIns="0" rIns="0" tIns="0" bIns="0">
+            <a:spAutoFit/>
+          </a:bodyPr>
+          <a:lstStyle/>
+          <a:p>
+            <a:pPr algn="l"/>
+            <a:r>
+              <a:rPr sz="1000" b="1" i="0">
                 <a:solidFill>
                   <a:srgbClr val="B5121B"/>
                 </a:solidFill>
                 <a:latin typeface="Arial"/>
               </a:rPr>
-              <a:t>Hawai'i +5.5 lean LOST</a:t>
+              <a:t>machine off by 8.5 · market off by 6 — market closer</a:t>
             </a:r>
           </a:p>
         </p:txBody>
@@ -11253,7 +11253,7 @@
                 </a:solidFill>
                 <a:latin typeface="Arial"/>
               </a:rPr>
-              <a:t>called UNLV 32–26 · final Memphis 27–21</a:t>
+              <a:t>we called UNLV 32–26 · FINAL Memphis 27–21</a:t>
             </a:r>
           </a:p>
         </p:txBody>
@@ -11266,8 +11266,8 @@
         </p:nvSpPr>
         <p:spPr>
           <a:xfrm>
-            <a:off x="6949440" y="4956048"/>
-            <a:ext cx="4160520" cy="274320"/>
+            <a:off x="6720840" y="4956048"/>
+            <a:ext cx="4389120" cy="274320"/>
           </a:xfrm>
           <a:prstGeom prst="rect">
             <a:avLst/>
@@ -11288,7 +11288,7 @@
                 </a:solidFill>
                 <a:latin typeface="Arial"/>
               </a:rPr>
-              <a:t>machine UNLV –6 · close –4 · actual MEM by 6</a:t>
+              <a:t>our line UNLV –6 · closing UNLV –4</a:t>
             </a:r>
           </a:p>
         </p:txBody>
@@ -11301,29 +11301,29 @@
         </p:nvSpPr>
         <p:spPr>
           <a:xfrm>
-            <a:off x="6949440" y="5257800"/>
-            <a:ext cx="4160520" cy="274320"/>
-          </a:xfrm>
-          <a:prstGeom prst="rect">
-            <a:avLst/>
-          </a:prstGeom>
-          <a:noFill/>
-        </p:spPr>
-        <p:txBody>
-          <a:bodyPr wrap="square" lIns="0" rIns="0" tIns="0" bIns="0">
-            <a:spAutoFit/>
-          </a:bodyPr>
-          <a:lstStyle/>
-          <a:p>
-            <a:pPr algn="l"/>
-            <a:r>
-              <a:rPr sz="1050" b="1" i="0">
-                <a:solidFill>
-                  <a:srgbClr val="5C6B7E"/>
-                </a:solidFill>
-                <a:latin typeface="Arial"/>
-              </a:rPr>
-              <a:t>watch only — machine's side lost</a:t>
+            <a:off x="6720840" y="5257800"/>
+            <a:ext cx="4389120" cy="274320"/>
+          </a:xfrm>
+          <a:prstGeom prst="rect">
+            <a:avLst/>
+          </a:prstGeom>
+          <a:noFill/>
+        </p:spPr>
+        <p:txBody>
+          <a:bodyPr wrap="square" lIns="0" rIns="0" tIns="0" bIns="0">
+            <a:spAutoFit/>
+          </a:bodyPr>
+          <a:lstStyle/>
+          <a:p>
+            <a:pPr algn="l"/>
+            <a:r>
+              <a:rPr sz="1000" b="1" i="0">
+                <a:solidFill>
+                  <a:srgbClr val="B5121B"/>
+                </a:solidFill>
+                <a:latin typeface="Arial"/>
+              </a:rPr>
+              <a:t>machine off by 12 · market off by 10 — market closer</a:t>
             </a:r>
           </a:p>
         </p:txBody>
@@ -11402,7 +11402,7 @@
                 </a:solidFill>
                 <a:latin typeface="Arial"/>
               </a:rPr>
-              <a:t>Accuracy: machine 13.9 avg margin miss vs closing market 14.0 — a dead heat in week one. Stated leans 1–2, and the win came in the game with our biggest market disagreement (18 points of win prob). Week 0 went UNDER in 4 of 5 · σ 17.9 — one week proves nothing either way.</a:t>
+              <a:t>Total miss across five games: machine 70.0 points, closing market 70.0 — a literal dead heat. Stated leans 1–2, the win coming where we disagreed with the market most (UNC, 18 points of win prob). Week 0 went UNDER in 4 of 5 · σ 17.9 — one week proves nothing either way.</a:t>
             </a:r>
           </a:p>
         </p:txBody>

</xml_diff>

<commit_message>
Title slide: current market line beside the machine number per game
Co-Authored-By: Claude Fable 5 <noreply@anthropic.com>
</commit_message>
<xml_diff>
--- a/decks/2026_Week1_Episode2.pptx
+++ b/decks/2026_Week1_Episode2.pptx
@@ -3436,8 +3436,8 @@
         </p:nvSpPr>
         <p:spPr>
           <a:xfrm>
-            <a:off x="8503920" y="2286000"/>
-            <a:ext cx="2651760" cy="365760"/>
+            <a:off x="7680960" y="2286000"/>
+            <a:ext cx="3474720" cy="365760"/>
           </a:xfrm>
           <a:prstGeom prst="rect">
             <a:avLst/>
@@ -3452,13 +3452,13 @@
           <a:p>
             <a:pPr algn="r"/>
             <a:r>
-              <a:rPr sz="1500" b="1" i="0">
+              <a:rPr sz="1350" b="1" i="0">
                 <a:solidFill>
                   <a:srgbClr val="F47321"/>
                 </a:solidFill>
                 <a:latin typeface="Arial"/>
               </a:rPr>
-              <a:t>Auburn –5.5</a:t>
+              <a:t>Auburn –5.5   ·   –7 / –7</a:t>
             </a:r>
           </a:p>
         </p:txBody>
@@ -3471,8 +3471,8 @@
         </p:nvSpPr>
         <p:spPr>
           <a:xfrm>
-            <a:off x="8503920" y="2624328"/>
-            <a:ext cx="2651760" cy="274320"/>
+            <a:off x="7680960" y="2624328"/>
+            <a:ext cx="3474720" cy="274320"/>
           </a:xfrm>
           <a:prstGeom prst="rect">
             <a:avLst/>
@@ -3493,7 +3493,7 @@
                 </a:solidFill>
                 <a:latin typeface="Arial"/>
               </a:rPr>
-              <a:t>machine</a:t>
+              <a:t>machine · market</a:t>
             </a:r>
           </a:p>
         </p:txBody>
@@ -3756,8 +3756,8 @@
         </p:nvSpPr>
         <p:spPr>
           <a:xfrm>
-            <a:off x="8503920" y="3090672"/>
-            <a:ext cx="2651760" cy="365760"/>
+            <a:off x="7680960" y="3090672"/>
+            <a:ext cx="3474720" cy="365760"/>
           </a:xfrm>
           <a:prstGeom prst="rect">
             <a:avLst/>
@@ -3772,13 +3772,13 @@
           <a:p>
             <a:pPr algn="r"/>
             <a:r>
-              <a:rPr sz="1500" b="1" i="0">
+              <a:rPr sz="1350" b="1" i="0">
                 <a:solidFill>
                   <a:srgbClr val="F47321"/>
                 </a:solidFill>
                 <a:latin typeface="Arial"/>
               </a:rPr>
-              <a:t>LSU –9</a:t>
+              <a:t>LSU –9   ·   –10.5 / –10.5</a:t>
             </a:r>
           </a:p>
         </p:txBody>
@@ -3791,8 +3791,8 @@
         </p:nvSpPr>
         <p:spPr>
           <a:xfrm>
-            <a:off x="8503920" y="3429000"/>
-            <a:ext cx="2651760" cy="274320"/>
+            <a:off x="7680960" y="3429000"/>
+            <a:ext cx="3474720" cy="274320"/>
           </a:xfrm>
           <a:prstGeom prst="rect">
             <a:avLst/>
@@ -3813,7 +3813,7 @@
                 </a:solidFill>
                 <a:latin typeface="Arial"/>
               </a:rPr>
-              <a:t>machine</a:t>
+              <a:t>machine · market</a:t>
             </a:r>
           </a:p>
         </p:txBody>
@@ -4076,8 +4076,8 @@
         </p:nvSpPr>
         <p:spPr>
           <a:xfrm>
-            <a:off x="8503920" y="3895344"/>
-            <a:ext cx="2651760" cy="365760"/>
+            <a:off x="7680960" y="3895344"/>
+            <a:ext cx="3474720" cy="365760"/>
           </a:xfrm>
           <a:prstGeom prst="rect">
             <a:avLst/>
@@ -4092,13 +4092,13 @@
           <a:p>
             <a:pPr algn="r"/>
             <a:r>
-              <a:rPr sz="1500" b="1" i="0">
+              <a:rPr sz="1350" b="1" i="0">
                 <a:solidFill>
                   <a:srgbClr val="F47321"/>
                 </a:solidFill>
                 <a:latin typeface="Arial"/>
               </a:rPr>
-              <a:t>Ole Miss –6.5</a:t>
+              <a:t>Ole Miss –6.5   ·   –7 / –6.5</a:t>
             </a:r>
           </a:p>
         </p:txBody>
@@ -4111,8 +4111,8 @@
         </p:nvSpPr>
         <p:spPr>
           <a:xfrm>
-            <a:off x="8503920" y="4233672"/>
-            <a:ext cx="2651760" cy="274320"/>
+            <a:off x="7680960" y="4233672"/>
+            <a:ext cx="3474720" cy="274320"/>
           </a:xfrm>
           <a:prstGeom prst="rect">
             <a:avLst/>
@@ -4133,7 +4133,7 @@
                 </a:solidFill>
                 <a:latin typeface="Arial"/>
               </a:rPr>
-              <a:t>machine</a:t>
+              <a:t>machine · market</a:t>
             </a:r>
           </a:p>
         </p:txBody>
@@ -4396,8 +4396,8 @@
         </p:nvSpPr>
         <p:spPr>
           <a:xfrm>
-            <a:off x="8503920" y="4700016"/>
-            <a:ext cx="2651760" cy="365760"/>
+            <a:off x="7680960" y="4700016"/>
+            <a:ext cx="3474720" cy="365760"/>
           </a:xfrm>
           <a:prstGeom prst="rect">
             <a:avLst/>
@@ -4412,13 +4412,13 @@
           <a:p>
             <a:pPr algn="r"/>
             <a:r>
-              <a:rPr sz="1500" b="1" i="0">
+              <a:rPr sz="1350" b="1" i="0">
                 <a:solidFill>
                   <a:srgbClr val="F47321"/>
                 </a:solidFill>
                 <a:latin typeface="Arial"/>
               </a:rPr>
-              <a:t>ND –21</a:t>
+              <a:t>ND –21   ·   –20.5 / –20</a:t>
             </a:r>
           </a:p>
         </p:txBody>
@@ -4431,8 +4431,8 @@
         </p:nvSpPr>
         <p:spPr>
           <a:xfrm>
-            <a:off x="8503920" y="5038344"/>
-            <a:ext cx="2651760" cy="274320"/>
+            <a:off x="7680960" y="5038344"/>
+            <a:ext cx="3474720" cy="274320"/>
           </a:xfrm>
           <a:prstGeom prst="rect">
             <a:avLst/>
@@ -4453,7 +4453,7 @@
                 </a:solidFill>
                 <a:latin typeface="Arial"/>
               </a:rPr>
-              <a:t>machine</a:t>
+              <a:t>machine · market</a:t>
             </a:r>
           </a:p>
         </p:txBody>
@@ -4716,8 +4716,8 @@
         </p:nvSpPr>
         <p:spPr>
           <a:xfrm>
-            <a:off x="8503920" y="5504688"/>
-            <a:ext cx="2651760" cy="365760"/>
+            <a:off x="7680960" y="5504688"/>
+            <a:ext cx="3474720" cy="365760"/>
           </a:xfrm>
           <a:prstGeom prst="rect">
             <a:avLst/>
@@ -4732,13 +4732,13 @@
           <a:p>
             <a:pPr algn="r"/>
             <a:r>
-              <a:rPr sz="1500" b="1" i="0">
+              <a:rPr sz="1350" b="1" i="0">
                 <a:solidFill>
                   <a:srgbClr val="F47321"/>
                 </a:solidFill>
                 <a:latin typeface="Arial"/>
               </a:rPr>
-              <a:t>FSU –0.5</a:t>
+              <a:t>FSU –0.5   ·   +3 / +3</a:t>
             </a:r>
           </a:p>
         </p:txBody>
@@ -4751,8 +4751,8 @@
         </p:nvSpPr>
         <p:spPr>
           <a:xfrm>
-            <a:off x="8503920" y="5843016"/>
-            <a:ext cx="2651760" cy="274320"/>
+            <a:off x="7680960" y="5843016"/>
+            <a:ext cx="3474720" cy="274320"/>
           </a:xfrm>
           <a:prstGeom prst="rect">
             <a:avLst/>
@@ -4773,7 +4773,7 @@
                 </a:solidFill>
                 <a:latin typeface="Arial"/>
               </a:rPr>
-              <a:t>machine</a:t>
+              <a:t>machine · market</a:t>
             </a:r>
           </a:p>
         </p:txBody>

</xml_diff>

<commit_message>
Superdog Picks slide: outright-dog boards, any-game + vs-AP-top-25
Computed live from card_data: EV = model outright win prob x spread,
played games excluded, DK spreads preferred. Ranked-favorite dogs live
on the Giant Killer panel only; most-likely ranked upset called out
(FSU +3 vs #19 SMU, the RED pick). AP Top 25 dict is week-1 - update
weekly. Honesty footer flags the favorite-longshot caveat.

Co-Authored-By: Claude Fable 5 <noreply@anthropic.com>
</commit_message>
<xml_diff>
--- a/decks/2026_Week1_Episode2.pptx
+++ b/decks/2026_Week1_Episode2.pptx
@@ -23,6 +23,7 @@
     <p:sldId id="271" r:id="rId22"/>
     <p:sldId id="272" r:id="rId23"/>
     <p:sldId id="273" r:id="rId24"/>
+    <p:sldId id="274" r:id="rId25"/>
   </p:sldIdLst>
   <p:sldSz cx="12191695" cy="6858000" type="screen4x3"/>
   <p:notesSz cx="6858000" cy="9144000"/>
@@ -11569,6 +11570,785 @@
 </file>
 
 <file path=ppt/slides/slide18.xml><?xml version="1.0" encoding="utf-8"?>
+<p:sld xmlns:a="http://schemas.openxmlformats.org/drawingml/2006/main" xmlns:p="http://schemas.openxmlformats.org/presentationml/2006/main" xmlns:r="http://schemas.openxmlformats.org/officeDocument/2006/relationships">
+  <p:cSld>
+    <p:bg>
+      <p:bgPr>
+        <a:solidFill>
+          <a:srgbClr val="FFFFFF"/>
+        </a:solidFill>
+        <a:effectLst/>
+      </p:bgPr>
+    </p:bg>
+    <p:spTree>
+      <p:nvGrpSpPr>
+        <p:cNvPr id="1" name=""/>
+        <p:cNvGrpSpPr/>
+        <p:nvPr/>
+      </p:nvGrpSpPr>
+      <p:grpSpPr/>
+      <p:sp>
+        <p:nvSpPr>
+          <p:cNvPr id="2" name="TextBox 1"/>
+          <p:cNvSpPr txBox="1"/>
+          <p:nvPr/>
+        </p:nvSpPr>
+        <p:spPr>
+          <a:xfrm>
+            <a:off x="822960" y="457200"/>
+            <a:ext cx="10515600" cy="502920"/>
+          </a:xfrm>
+          <a:prstGeom prst="rect">
+            <a:avLst/>
+          </a:prstGeom>
+          <a:noFill/>
+        </p:spPr>
+        <p:txBody>
+          <a:bodyPr wrap="square" lIns="0" rIns="0" tIns="0" bIns="0">
+            <a:spAutoFit/>
+          </a:bodyPr>
+          <a:lstStyle/>
+          <a:p>
+            <a:pPr algn="l"/>
+            <a:r>
+              <a:rPr sz="3000" b="1" i="0">
+                <a:solidFill>
+                  <a:srgbClr val="0A2851"/>
+                </a:solidFill>
+                <a:latin typeface="Arial"/>
+              </a:rPr>
+              <a:t>Superdog Picks</a:t>
+            </a:r>
+          </a:p>
+        </p:txBody>
+      </p:sp>
+      <p:sp>
+        <p:nvSpPr>
+          <p:cNvPr id="3" name="TextBox 2"/>
+          <p:cNvSpPr txBox="1"/>
+          <p:nvPr/>
+        </p:nvSpPr>
+        <p:spPr>
+          <a:xfrm>
+            <a:off x="822960" y="987552"/>
+            <a:ext cx="10515600" cy="274320"/>
+          </a:xfrm>
+          <a:prstGeom prst="rect">
+            <a:avLst/>
+          </a:prstGeom>
+          <a:noFill/>
+        </p:spPr>
+        <p:txBody>
+          <a:bodyPr wrap="square" lIns="0" rIns="0" tIns="0" bIns="0">
+            <a:spAutoFit/>
+          </a:bodyPr>
+          <a:lstStyle/>
+          <a:p>
+            <a:pPr algn="l"/>
+            <a:r>
+              <a:rPr sz="1100" b="0" i="1">
+                <a:solidFill>
+                  <a:srgbClr val="5C6B7E"/>
+                </a:solidFill>
+                <a:latin typeface="Arial"/>
+              </a:rPr>
+              <a:t>Pick a dog to WIN OUTRIGHT — points = the spread · machine board: model win prob vs market, expected points = prob × spread</a:t>
+            </a:r>
+          </a:p>
+        </p:txBody>
+      </p:sp>
+      <p:sp>
+        <p:nvSpPr>
+          <p:cNvPr id="4" name="Rounded Rectangle 3"/>
+          <p:cNvSpPr/>
+          <p:nvPr/>
+        </p:nvSpPr>
+        <p:spPr>
+          <a:xfrm>
+            <a:off x="822960" y="1463040"/>
+            <a:ext cx="5074920" cy="4480560"/>
+          </a:xfrm>
+          <a:prstGeom prst="roundRect">
+            <a:avLst/>
+          </a:prstGeom>
+          <a:solidFill>
+            <a:srgbClr val="EAF0F8"/>
+          </a:solidFill>
+          <a:ln>
+            <a:noFill/>
+          </a:ln>
+          <a:effectLst/>
+        </p:spPr>
+        <p:style>
+          <a:lnRef idx="1">
+            <a:schemeClr val="accent1"/>
+          </a:lnRef>
+          <a:fillRef idx="3">
+            <a:schemeClr val="accent1"/>
+          </a:fillRef>
+          <a:effectRef idx="2">
+            <a:schemeClr val="accent1"/>
+          </a:effectRef>
+          <a:fontRef idx="minor">
+            <a:schemeClr val="lt1"/>
+          </a:fontRef>
+        </p:style>
+        <p:txBody>
+          <a:bodyPr rtlCol="0" anchor="ctr"/>
+          <a:lstStyle/>
+          <a:p>
+            <a:pPr algn="ctr"/>
+          </a:p>
+        </p:txBody>
+      </p:sp>
+      <p:sp>
+        <p:nvSpPr>
+          <p:cNvPr id="5" name="TextBox 4"/>
+          <p:cNvSpPr txBox="1"/>
+          <p:nvPr/>
+        </p:nvSpPr>
+        <p:spPr>
+          <a:xfrm>
+            <a:off x="1097280" y="1645920"/>
+            <a:ext cx="4572000" cy="274320"/>
+          </a:xfrm>
+          <a:prstGeom prst="rect">
+            <a:avLst/>
+          </a:prstGeom>
+          <a:noFill/>
+        </p:spPr>
+        <p:txBody>
+          <a:bodyPr wrap="square" lIns="0" rIns="0" tIns="0" bIns="0">
+            <a:spAutoFit/>
+          </a:bodyPr>
+          <a:lstStyle/>
+          <a:p>
+            <a:pPr algn="l"/>
+            <a:r>
+              <a:rPr sz="1200" b="1" i="0">
+                <a:solidFill>
+                  <a:srgbClr val="F47321"/>
+                </a:solidFill>
+                <a:latin typeface="Arial"/>
+              </a:rPr>
+              <a:t>ANY GAME</a:t>
+            </a:r>
+          </a:p>
+        </p:txBody>
+      </p:sp>
+      <p:sp>
+        <p:nvSpPr>
+          <p:cNvPr id="6" name="TextBox 5"/>
+          <p:cNvSpPr txBox="1"/>
+          <p:nvPr/>
+        </p:nvSpPr>
+        <p:spPr>
+          <a:xfrm>
+            <a:off x="1097280" y="2057400"/>
+            <a:ext cx="4572000" cy="320040"/>
+          </a:xfrm>
+          <a:prstGeom prst="rect">
+            <a:avLst/>
+          </a:prstGeom>
+          <a:noFill/>
+        </p:spPr>
+        <p:txBody>
+          <a:bodyPr wrap="square" lIns="0" rIns="0" tIns="0" bIns="0">
+            <a:spAutoFit/>
+          </a:bodyPr>
+          <a:lstStyle/>
+          <a:p>
+            <a:pPr algn="l"/>
+            <a:r>
+              <a:rPr sz="1300" b="1" i="0">
+                <a:solidFill>
+                  <a:srgbClr val="F47321"/>
+                </a:solidFill>
+                <a:latin typeface="Arial"/>
+              </a:rPr>
+              <a:t>★ Coastal Carolina +21.5 at West Virginia</a:t>
+            </a:r>
+          </a:p>
+        </p:txBody>
+      </p:sp>
+      <p:sp>
+        <p:nvSpPr>
+          <p:cNvPr id="7" name="TextBox 6"/>
+          <p:cNvSpPr txBox="1"/>
+          <p:nvPr/>
+        </p:nvSpPr>
+        <p:spPr>
+          <a:xfrm>
+            <a:off x="1097280" y="2386584"/>
+            <a:ext cx="4572000" cy="274320"/>
+          </a:xfrm>
+          <a:prstGeom prst="rect">
+            <a:avLst/>
+          </a:prstGeom>
+          <a:noFill/>
+        </p:spPr>
+        <p:txBody>
+          <a:bodyPr wrap="square" lIns="0" rIns="0" tIns="0" bIns="0">
+            <a:spAutoFit/>
+          </a:bodyPr>
+          <a:lstStyle/>
+          <a:p>
+            <a:pPr algn="l"/>
+            <a:r>
+              <a:rPr sz="1000" b="0" i="0">
+                <a:solidFill>
+                  <a:srgbClr val="5C6B7E"/>
+                </a:solidFill>
+                <a:latin typeface="Arial"/>
+              </a:rPr>
+              <a:t>model 21% · market 9% · expected pts 4.4</a:t>
+            </a:r>
+          </a:p>
+        </p:txBody>
+      </p:sp>
+      <p:sp>
+        <p:nvSpPr>
+          <p:cNvPr id="8" name="TextBox 7"/>
+          <p:cNvSpPr txBox="1"/>
+          <p:nvPr/>
+        </p:nvSpPr>
+        <p:spPr>
+          <a:xfrm>
+            <a:off x="1097280" y="2926080"/>
+            <a:ext cx="4572000" cy="320040"/>
+          </a:xfrm>
+          <a:prstGeom prst="rect">
+            <a:avLst/>
+          </a:prstGeom>
+          <a:noFill/>
+        </p:spPr>
+        <p:txBody>
+          <a:bodyPr wrap="square" lIns="0" rIns="0" tIns="0" bIns="0">
+            <a:spAutoFit/>
+          </a:bodyPr>
+          <a:lstStyle/>
+          <a:p>
+            <a:pPr algn="l"/>
+            <a:r>
+              <a:rPr sz="1200" b="1" i="0">
+                <a:solidFill>
+                  <a:srgbClr val="16273D"/>
+                </a:solidFill>
+                <a:latin typeface="Arial"/>
+              </a:rPr>
+              <a:t>Tulsa +14 vs Oklahoma State</a:t>
+            </a:r>
+          </a:p>
+        </p:txBody>
+      </p:sp>
+      <p:sp>
+        <p:nvSpPr>
+          <p:cNvPr id="9" name="TextBox 8"/>
+          <p:cNvSpPr txBox="1"/>
+          <p:nvPr/>
+        </p:nvSpPr>
+        <p:spPr>
+          <a:xfrm>
+            <a:off x="1097280" y="3255264"/>
+            <a:ext cx="4572000" cy="274320"/>
+          </a:xfrm>
+          <a:prstGeom prst="rect">
+            <a:avLst/>
+          </a:prstGeom>
+          <a:noFill/>
+        </p:spPr>
+        <p:txBody>
+          <a:bodyPr wrap="square" lIns="0" rIns="0" tIns="0" bIns="0">
+            <a:spAutoFit/>
+          </a:bodyPr>
+          <a:lstStyle/>
+          <a:p>
+            <a:pPr algn="l"/>
+            <a:r>
+              <a:rPr sz="1000" b="0" i="0">
+                <a:solidFill>
+                  <a:srgbClr val="5C6B7E"/>
+                </a:solidFill>
+                <a:latin typeface="Arial"/>
+              </a:rPr>
+              <a:t>model 30% · market 18% · expected pts 4.2</a:t>
+            </a:r>
+          </a:p>
+        </p:txBody>
+      </p:sp>
+      <p:sp>
+        <p:nvSpPr>
+          <p:cNvPr id="10" name="TextBox 9"/>
+          <p:cNvSpPr txBox="1"/>
+          <p:nvPr/>
+        </p:nvSpPr>
+        <p:spPr>
+          <a:xfrm>
+            <a:off x="1097280" y="3794760"/>
+            <a:ext cx="4572000" cy="320040"/>
+          </a:xfrm>
+          <a:prstGeom prst="rect">
+            <a:avLst/>
+          </a:prstGeom>
+          <a:noFill/>
+        </p:spPr>
+        <p:txBody>
+          <a:bodyPr wrap="square" lIns="0" rIns="0" tIns="0" bIns="0">
+            <a:spAutoFit/>
+          </a:bodyPr>
+          <a:lstStyle/>
+          <a:p>
+            <a:pPr algn="l"/>
+            <a:r>
+              <a:rPr sz="1200" b="1" i="0">
+                <a:solidFill>
+                  <a:srgbClr val="16273D"/>
+                </a:solidFill>
+                <a:latin typeface="Arial"/>
+              </a:rPr>
+              <a:t>Tulane +9.5 at Duke</a:t>
+            </a:r>
+          </a:p>
+        </p:txBody>
+      </p:sp>
+      <p:sp>
+        <p:nvSpPr>
+          <p:cNvPr id="11" name="TextBox 10"/>
+          <p:cNvSpPr txBox="1"/>
+          <p:nvPr/>
+        </p:nvSpPr>
+        <p:spPr>
+          <a:xfrm>
+            <a:off x="1097280" y="4123944"/>
+            <a:ext cx="4572000" cy="274320"/>
+          </a:xfrm>
+          <a:prstGeom prst="rect">
+            <a:avLst/>
+          </a:prstGeom>
+          <a:noFill/>
+        </p:spPr>
+        <p:txBody>
+          <a:bodyPr wrap="square" lIns="0" rIns="0" tIns="0" bIns="0">
+            <a:spAutoFit/>
+          </a:bodyPr>
+          <a:lstStyle/>
+          <a:p>
+            <a:pPr algn="l"/>
+            <a:r>
+              <a:rPr sz="1000" b="0" i="0">
+                <a:solidFill>
+                  <a:srgbClr val="5C6B7E"/>
+                </a:solidFill>
+                <a:latin typeface="Arial"/>
+              </a:rPr>
+              <a:t>model 41% · market 24% · expected pts 3.9</a:t>
+            </a:r>
+          </a:p>
+        </p:txBody>
+      </p:sp>
+      <p:sp>
+        <p:nvSpPr>
+          <p:cNvPr id="12" name="Rounded Rectangle 11"/>
+          <p:cNvSpPr/>
+          <p:nvPr/>
+        </p:nvSpPr>
+        <p:spPr>
+          <a:xfrm>
+            <a:off x="6263640" y="1463040"/>
+            <a:ext cx="5074920" cy="4480560"/>
+          </a:xfrm>
+          <a:prstGeom prst="roundRect">
+            <a:avLst/>
+          </a:prstGeom>
+          <a:solidFill>
+            <a:srgbClr val="EAF0F8"/>
+          </a:solidFill>
+          <a:ln>
+            <a:noFill/>
+          </a:ln>
+          <a:effectLst/>
+        </p:spPr>
+        <p:style>
+          <a:lnRef idx="1">
+            <a:schemeClr val="accent1"/>
+          </a:lnRef>
+          <a:fillRef idx="3">
+            <a:schemeClr val="accent1"/>
+          </a:fillRef>
+          <a:effectRef idx="2">
+            <a:schemeClr val="accent1"/>
+          </a:effectRef>
+          <a:fontRef idx="minor">
+            <a:schemeClr val="lt1"/>
+          </a:fontRef>
+        </p:style>
+        <p:txBody>
+          <a:bodyPr rtlCol="0" anchor="ctr"/>
+          <a:lstStyle/>
+          <a:p>
+            <a:pPr algn="ctr"/>
+          </a:p>
+        </p:txBody>
+      </p:sp>
+      <p:sp>
+        <p:nvSpPr>
+          <p:cNvPr id="13" name="TextBox 12"/>
+          <p:cNvSpPr txBox="1"/>
+          <p:nvPr/>
+        </p:nvSpPr>
+        <p:spPr>
+          <a:xfrm>
+            <a:off x="6537960" y="1645920"/>
+            <a:ext cx="4572000" cy="274320"/>
+          </a:xfrm>
+          <a:prstGeom prst="rect">
+            <a:avLst/>
+          </a:prstGeom>
+          <a:noFill/>
+        </p:spPr>
+        <p:txBody>
+          <a:bodyPr wrap="square" lIns="0" rIns="0" tIns="0" bIns="0">
+            <a:spAutoFit/>
+          </a:bodyPr>
+          <a:lstStyle/>
+          <a:p>
+            <a:pPr algn="l"/>
+            <a:r>
+              <a:rPr sz="1200" b="1" i="0">
+                <a:solidFill>
+                  <a:srgbClr val="F47321"/>
+                </a:solidFill>
+                <a:latin typeface="Arial"/>
+              </a:rPr>
+              <a:t>GIANT KILLER — dog vs an AP top-25 team</a:t>
+            </a:r>
+          </a:p>
+        </p:txBody>
+      </p:sp>
+      <p:sp>
+        <p:nvSpPr>
+          <p:cNvPr id="14" name="TextBox 13"/>
+          <p:cNvSpPr txBox="1"/>
+          <p:nvPr/>
+        </p:nvSpPr>
+        <p:spPr>
+          <a:xfrm>
+            <a:off x="6537960" y="2057400"/>
+            <a:ext cx="4572000" cy="320040"/>
+          </a:xfrm>
+          <a:prstGeom prst="rect">
+            <a:avLst/>
+          </a:prstGeom>
+          <a:noFill/>
+        </p:spPr>
+        <p:txBody>
+          <a:bodyPr wrap="square" lIns="0" rIns="0" tIns="0" bIns="0">
+            <a:spAutoFit/>
+          </a:bodyPr>
+          <a:lstStyle/>
+          <a:p>
+            <a:pPr algn="l"/>
+            <a:r>
+              <a:rPr sz="1300" b="1" i="0">
+                <a:solidFill>
+                  <a:srgbClr val="F47321"/>
+                </a:solidFill>
+                <a:latin typeface="Arial"/>
+              </a:rPr>
+              <a:t>★ Washington State +23.5 at #17 Washington</a:t>
+            </a:r>
+          </a:p>
+        </p:txBody>
+      </p:sp>
+      <p:sp>
+        <p:nvSpPr>
+          <p:cNvPr id="15" name="TextBox 14"/>
+          <p:cNvSpPr txBox="1"/>
+          <p:nvPr/>
+        </p:nvSpPr>
+        <p:spPr>
+          <a:xfrm>
+            <a:off x="6537960" y="2386584"/>
+            <a:ext cx="4572000" cy="274320"/>
+          </a:xfrm>
+          <a:prstGeom prst="rect">
+            <a:avLst/>
+          </a:prstGeom>
+          <a:noFill/>
+        </p:spPr>
+        <p:txBody>
+          <a:bodyPr wrap="square" lIns="0" rIns="0" tIns="0" bIns="0">
+            <a:spAutoFit/>
+          </a:bodyPr>
+          <a:lstStyle/>
+          <a:p>
+            <a:pPr algn="l"/>
+            <a:r>
+              <a:rPr sz="1000" b="0" i="0">
+                <a:solidFill>
+                  <a:srgbClr val="5C6B7E"/>
+                </a:solidFill>
+                <a:latin typeface="Arial"/>
+              </a:rPr>
+              <a:t>model 18% · market 7% · expected pts 4.3</a:t>
+            </a:r>
+          </a:p>
+        </p:txBody>
+      </p:sp>
+      <p:sp>
+        <p:nvSpPr>
+          <p:cNvPr id="16" name="TextBox 15"/>
+          <p:cNvSpPr txBox="1"/>
+          <p:nvPr/>
+        </p:nvSpPr>
+        <p:spPr>
+          <a:xfrm>
+            <a:off x="6537960" y="2926080"/>
+            <a:ext cx="4572000" cy="320040"/>
+          </a:xfrm>
+          <a:prstGeom prst="rect">
+            <a:avLst/>
+          </a:prstGeom>
+          <a:noFill/>
+        </p:spPr>
+        <p:txBody>
+          <a:bodyPr wrap="square" lIns="0" rIns="0" tIns="0" bIns="0">
+            <a:spAutoFit/>
+          </a:bodyPr>
+          <a:lstStyle/>
+          <a:p>
+            <a:pPr algn="l"/>
+            <a:r>
+              <a:rPr sz="1200" b="1" i="0">
+                <a:solidFill>
+                  <a:srgbClr val="16273D"/>
+                </a:solidFill>
+                <a:latin typeface="Arial"/>
+              </a:rPr>
+              <a:t>Oregon State +20.5 at #23 Houston</a:t>
+            </a:r>
+          </a:p>
+        </p:txBody>
+      </p:sp>
+      <p:sp>
+        <p:nvSpPr>
+          <p:cNvPr id="17" name="TextBox 16"/>
+          <p:cNvSpPr txBox="1"/>
+          <p:nvPr/>
+        </p:nvSpPr>
+        <p:spPr>
+          <a:xfrm>
+            <a:off x="6537960" y="3255264"/>
+            <a:ext cx="4572000" cy="274320"/>
+          </a:xfrm>
+          <a:prstGeom prst="rect">
+            <a:avLst/>
+          </a:prstGeom>
+          <a:noFill/>
+        </p:spPr>
+        <p:txBody>
+          <a:bodyPr wrap="square" lIns="0" rIns="0" tIns="0" bIns="0">
+            <a:spAutoFit/>
+          </a:bodyPr>
+          <a:lstStyle/>
+          <a:p>
+            <a:pPr algn="l"/>
+            <a:r>
+              <a:rPr sz="1000" b="0" i="0">
+                <a:solidFill>
+                  <a:srgbClr val="5C6B7E"/>
+                </a:solidFill>
+                <a:latin typeface="Arial"/>
+              </a:rPr>
+              <a:t>model 17% · market 9% · expected pts 3.4</a:t>
+            </a:r>
+          </a:p>
+        </p:txBody>
+      </p:sp>
+      <p:sp>
+        <p:nvSpPr>
+          <p:cNvPr id="18" name="TextBox 17"/>
+          <p:cNvSpPr txBox="1"/>
+          <p:nvPr/>
+        </p:nvSpPr>
+        <p:spPr>
+          <a:xfrm>
+            <a:off x="6537960" y="3794760"/>
+            <a:ext cx="4572000" cy="320040"/>
+          </a:xfrm>
+          <a:prstGeom prst="rect">
+            <a:avLst/>
+          </a:prstGeom>
+          <a:noFill/>
+        </p:spPr>
+        <p:txBody>
+          <a:bodyPr wrap="square" lIns="0" rIns="0" tIns="0" bIns="0">
+            <a:spAutoFit/>
+          </a:bodyPr>
+          <a:lstStyle/>
+          <a:p>
+            <a:pPr algn="l"/>
+            <a:r>
+              <a:rPr sz="1200" b="1" i="0">
+                <a:solidFill>
+                  <a:srgbClr val="16273D"/>
+                </a:solidFill>
+                <a:latin typeface="Arial"/>
+              </a:rPr>
+              <a:t>Clemson +10.5 at #11 LSU</a:t>
+            </a:r>
+          </a:p>
+        </p:txBody>
+      </p:sp>
+      <p:sp>
+        <p:nvSpPr>
+          <p:cNvPr id="19" name="TextBox 18"/>
+          <p:cNvSpPr txBox="1"/>
+          <p:nvPr/>
+        </p:nvSpPr>
+        <p:spPr>
+          <a:xfrm>
+            <a:off x="6537960" y="4123944"/>
+            <a:ext cx="4572000" cy="274320"/>
+          </a:xfrm>
+          <a:prstGeom prst="rect">
+            <a:avLst/>
+          </a:prstGeom>
+          <a:noFill/>
+        </p:spPr>
+        <p:txBody>
+          <a:bodyPr wrap="square" lIns="0" rIns="0" tIns="0" bIns="0">
+            <a:spAutoFit/>
+          </a:bodyPr>
+          <a:lstStyle/>
+          <a:p>
+            <a:pPr algn="l"/>
+            <a:r>
+              <a:rPr sz="1000" b="0" i="0">
+                <a:solidFill>
+                  <a:srgbClr val="5C6B7E"/>
+                </a:solidFill>
+                <a:latin typeface="Arial"/>
+              </a:rPr>
+              <a:t>model 30% · market 24% · expected pts 3.2</a:t>
+            </a:r>
+          </a:p>
+        </p:txBody>
+      </p:sp>
+      <p:sp>
+        <p:nvSpPr>
+          <p:cNvPr id="20" name="TextBox 19"/>
+          <p:cNvSpPr txBox="1"/>
+          <p:nvPr/>
+        </p:nvSpPr>
+        <p:spPr>
+          <a:xfrm>
+            <a:off x="6537960" y="4892040"/>
+            <a:ext cx="4572000" cy="822960"/>
+          </a:xfrm>
+          <a:prstGeom prst="rect">
+            <a:avLst/>
+          </a:prstGeom>
+          <a:noFill/>
+        </p:spPr>
+        <p:txBody>
+          <a:bodyPr wrap="square" lIns="0" rIns="0" tIns="0" bIns="0">
+            <a:spAutoFit/>
+          </a:bodyPr>
+          <a:lstStyle/>
+          <a:p>
+            <a:pPr algn="l"/>
+            <a:r>
+              <a:rPr sz="1050" b="0" i="1">
+                <a:solidFill>
+                  <a:srgbClr val="16273D"/>
+                </a:solidFill>
+                <a:latin typeface="Arial"/>
+              </a:rPr>
+              <a:t>Most likely ranked upset: Florida State +3 vs #19 SMU — 52% (low points, high cash rate)</a:t>
+            </a:r>
+          </a:p>
+        </p:txBody>
+      </p:sp>
+      <p:sp>
+        <p:nvSpPr>
+          <p:cNvPr id="21" name="TextBox 20"/>
+          <p:cNvSpPr txBox="1"/>
+          <p:nvPr/>
+        </p:nvSpPr>
+        <p:spPr>
+          <a:xfrm>
+            <a:off x="822960" y="6126480"/>
+            <a:ext cx="10515600" cy="457200"/>
+          </a:xfrm>
+          <a:prstGeom prst="rect">
+            <a:avLst/>
+          </a:prstGeom>
+          <a:noFill/>
+        </p:spPr>
+        <p:txBody>
+          <a:bodyPr wrap="square" lIns="0" rIns="0" tIns="0" bIns="0">
+            <a:spAutoFit/>
+          </a:bodyPr>
+          <a:lstStyle/>
+          <a:p>
+            <a:pPr algn="l"/>
+            <a:r>
+              <a:rPr sz="1000" b="0" i="1">
+                <a:solidFill>
+                  <a:srgbClr val="5C6B7E"/>
+                </a:solidFill>
+                <a:latin typeface="Arial"/>
+              </a:rPr>
+              <a:t>Honesty: model probs ride preseason priors and σ 17.9 — the biggest model-vs-market gaps sit exactly where the favorite-longshot bias lives. A points game between hosts, not a betting card.</a:t>
+            </a:r>
+          </a:p>
+        </p:txBody>
+      </p:sp>
+      <p:sp>
+        <p:nvSpPr>
+          <p:cNvPr id="22" name="TextBox 21"/>
+          <p:cNvSpPr txBox="1"/>
+          <p:nvPr/>
+        </p:nvSpPr>
+        <p:spPr>
+          <a:xfrm>
+            <a:off x="822960" y="6519672"/>
+            <a:ext cx="10515600" cy="274320"/>
+          </a:xfrm>
+          <a:prstGeom prst="rect">
+            <a:avLst/>
+          </a:prstGeom>
+          <a:noFill/>
+        </p:spPr>
+        <p:txBody>
+          <a:bodyPr wrap="square" lIns="0" rIns="0" tIns="0" bIns="0">
+            <a:spAutoFit/>
+          </a:bodyPr>
+          <a:lstStyle/>
+          <a:p>
+            <a:pPr algn="l"/>
+            <a:r>
+              <a:rPr sz="900" b="0" i="0">
+                <a:solidFill>
+                  <a:srgbClr val="5C6B7E"/>
+                </a:solidFill>
+                <a:latin typeface="Arial"/>
+              </a:rPr>
+              <a:t>EP 2 · WEEK 1 · SUPERDOG PICKS</a:t>
+            </a:r>
+          </a:p>
+        </p:txBody>
+      </p:sp>
+    </p:spTree>
+  </p:cSld>
+  <p:clrMapOvr>
+    <a:masterClrMapping/>
+  </p:clrMapOvr>
+</p:sld>
+</file>
+
+<file path=ppt/slides/slide19.xml><?xml version="1.0" encoding="utf-8"?>
 <p:sld xmlns:a="http://schemas.openxmlformats.org/drawingml/2006/main" xmlns:p="http://schemas.openxmlformats.org/presentationml/2006/main" xmlns:r="http://schemas.openxmlformats.org/officeDocument/2006/relationships">
   <p:cSld>
     <p:bg>

</xml_diff>

<commit_message>
Superdog slide: single pick per category with a weekly note line
Co-Authored-By: Claude Fable 5 <noreply@anthropic.com>
</commit_message>
<xml_diff>
--- a/decks/2026_Week1_Episode2.pptx
+++ b/decks/2026_Week1_Episode2.pptx
@@ -11665,8 +11665,8 @@
         </p:nvSpPr>
         <p:spPr>
           <a:xfrm>
-            <a:off x="822960" y="1463040"/>
-            <a:ext cx="5074920" cy="4480560"/>
+            <a:off x="822960" y="1554480"/>
+            <a:ext cx="5074920" cy="2834640"/>
           </a:xfrm>
           <a:prstGeom prst="roundRect">
             <a:avLst/>
@@ -11709,7 +11709,7 @@
         </p:nvSpPr>
         <p:spPr>
           <a:xfrm>
-            <a:off x="1097280" y="1645920"/>
+            <a:off x="1097280" y="1783080"/>
             <a:ext cx="4572000" cy="274320"/>
           </a:xfrm>
           <a:prstGeom prst="rect">
@@ -11744,23 +11744,23 @@
         </p:nvSpPr>
         <p:spPr>
           <a:xfrm>
-            <a:off x="1097280" y="2057400"/>
-            <a:ext cx="4572000" cy="320040"/>
-          </a:xfrm>
-          <a:prstGeom prst="rect">
-            <a:avLst/>
-          </a:prstGeom>
-          <a:noFill/>
-        </p:spPr>
-        <p:txBody>
-          <a:bodyPr wrap="square" lIns="0" rIns="0" tIns="0" bIns="0">
-            <a:spAutoFit/>
-          </a:bodyPr>
-          <a:lstStyle/>
-          <a:p>
-            <a:pPr algn="l"/>
-            <a:r>
-              <a:rPr sz="1300" b="1" i="0">
+            <a:off x="1097280" y="2240280"/>
+            <a:ext cx="4572000" cy="457200"/>
+          </a:xfrm>
+          <a:prstGeom prst="rect">
+            <a:avLst/>
+          </a:prstGeom>
+          <a:noFill/>
+        </p:spPr>
+        <p:txBody>
+          <a:bodyPr wrap="square" lIns="0" rIns="0" tIns="0" bIns="0">
+            <a:spAutoFit/>
+          </a:bodyPr>
+          <a:lstStyle/>
+          <a:p>
+            <a:pPr algn="l"/>
+            <a:r>
+              <a:rPr sz="1700" b="1" i="0">
                 <a:solidFill>
                   <a:srgbClr val="F47321"/>
                 </a:solidFill>
@@ -11779,7 +11779,7 @@
         </p:nvSpPr>
         <p:spPr>
           <a:xfrm>
-            <a:off x="1097280" y="2386584"/>
+            <a:off x="1097280" y="2788920"/>
             <a:ext cx="4572000" cy="274320"/>
           </a:xfrm>
           <a:prstGeom prst="rect">
@@ -11795,13 +11795,13 @@
           <a:p>
             <a:pPr algn="l"/>
             <a:r>
-              <a:rPr sz="1000" b="0" i="0">
+              <a:rPr sz="1050" b="0" i="0">
                 <a:solidFill>
                   <a:srgbClr val="5C6B7E"/>
                 </a:solidFill>
                 <a:latin typeface="Arial"/>
               </a:rPr>
-              <a:t>model 21% · market 9% · expected pts 4.4</a:t>
+              <a:t>model 21% to win outright · market 9% · expected pts 4.4</a:t>
             </a:r>
           </a:p>
         </p:txBody>
@@ -11814,148 +11814,43 @@
         </p:nvSpPr>
         <p:spPr>
           <a:xfrm>
-            <a:off x="1097280" y="2926080"/>
-            <a:ext cx="4572000" cy="320040"/>
-          </a:xfrm>
-          <a:prstGeom prst="rect">
-            <a:avLst/>
-          </a:prstGeom>
-          <a:noFill/>
-        </p:spPr>
-        <p:txBody>
-          <a:bodyPr wrap="square" lIns="0" rIns="0" tIns="0" bIns="0">
-            <a:spAutoFit/>
-          </a:bodyPr>
-          <a:lstStyle/>
-          <a:p>
-            <a:pPr algn="l"/>
-            <a:r>
-              <a:rPr sz="1200" b="1" i="0">
+            <a:off x="1097280" y="3246120"/>
+            <a:ext cx="4572000" cy="868680"/>
+          </a:xfrm>
+          <a:prstGeom prst="rect">
+            <a:avLst/>
+          </a:prstGeom>
+          <a:noFill/>
+        </p:spPr>
+        <p:txBody>
+          <a:bodyPr wrap="square" lIns="0" rIns="0" tIns="0" bIns="0">
+            <a:spAutoFit/>
+          </a:bodyPr>
+          <a:lstStyle/>
+          <a:p>
+            <a:pPr algn="l"/>
+            <a:r>
+              <a:rPr sz="1100" b="0" i="1">
                 <a:solidFill>
                   <a:srgbClr val="16273D"/>
                 </a:solidFill>
                 <a:latin typeface="Arial"/>
               </a:rPr>
-              <a:t>Tulsa +14 vs Oklahoma State</a:t>
-            </a:r>
-          </a:p>
-        </p:txBody>
-      </p:sp>
-      <p:sp>
-        <p:nvSpPr>
-          <p:cNvPr id="9" name="TextBox 8"/>
-          <p:cNvSpPr txBox="1"/>
-          <p:nvPr/>
-        </p:nvSpPr>
-        <p:spPr>
-          <a:xfrm>
-            <a:off x="1097280" y="3255264"/>
-            <a:ext cx="4572000" cy="274320"/>
-          </a:xfrm>
-          <a:prstGeom prst="rect">
-            <a:avLst/>
-          </a:prstGeom>
-          <a:noFill/>
-        </p:spPr>
-        <p:txBody>
-          <a:bodyPr wrap="square" lIns="0" rIns="0" tIns="0" bIns="0">
-            <a:spAutoFit/>
-          </a:bodyPr>
-          <a:lstStyle/>
-          <a:p>
-            <a:pPr algn="l"/>
-            <a:r>
-              <a:rPr sz="1000" b="0" i="0">
-                <a:solidFill>
-                  <a:srgbClr val="5C6B7E"/>
-                </a:solidFill>
-                <a:latin typeface="Arial"/>
-              </a:rPr>
-              <a:t>model 30% · market 18% · expected pts 4.2</a:t>
-            </a:r>
-          </a:p>
-        </p:txBody>
-      </p:sp>
-      <p:sp>
-        <p:nvSpPr>
-          <p:cNvPr id="10" name="TextBox 9"/>
-          <p:cNvSpPr txBox="1"/>
-          <p:nvPr/>
-        </p:nvSpPr>
-        <p:spPr>
-          <a:xfrm>
-            <a:off x="1097280" y="3794760"/>
-            <a:ext cx="4572000" cy="320040"/>
-          </a:xfrm>
-          <a:prstGeom prst="rect">
-            <a:avLst/>
-          </a:prstGeom>
-          <a:noFill/>
-        </p:spPr>
-        <p:txBody>
-          <a:bodyPr wrap="square" lIns="0" rIns="0" tIns="0" bIns="0">
-            <a:spAutoFit/>
-          </a:bodyPr>
-          <a:lstStyle/>
-          <a:p>
-            <a:pPr algn="l"/>
-            <a:r>
-              <a:rPr sz="1200" b="1" i="0">
-                <a:solidFill>
-                  <a:srgbClr val="16273D"/>
-                </a:solidFill>
-                <a:latin typeface="Arial"/>
-              </a:rPr>
-              <a:t>Tulane +9.5 at Duke</a:t>
-            </a:r>
-          </a:p>
-        </p:txBody>
-      </p:sp>
-      <p:sp>
-        <p:nvSpPr>
-          <p:cNvPr id="11" name="TextBox 10"/>
-          <p:cNvSpPr txBox="1"/>
-          <p:nvPr/>
-        </p:nvSpPr>
-        <p:spPr>
-          <a:xfrm>
-            <a:off x="1097280" y="4123944"/>
-            <a:ext cx="4572000" cy="274320"/>
-          </a:xfrm>
-          <a:prstGeom prst="rect">
-            <a:avLst/>
-          </a:prstGeom>
-          <a:noFill/>
-        </p:spPr>
-        <p:txBody>
-          <a:bodyPr wrap="square" lIns="0" rIns="0" tIns="0" bIns="0">
-            <a:spAutoFit/>
-          </a:bodyPr>
-          <a:lstStyle/>
-          <a:p>
-            <a:pPr algn="l"/>
-            <a:r>
-              <a:rPr sz="1000" b="0" i="0">
-                <a:solidFill>
-                  <a:srgbClr val="5C6B7E"/>
-                </a:solidFill>
-                <a:latin typeface="Arial"/>
-              </a:rPr>
-              <a:t>model 41% · market 24% · expected pts 3.9</a:t>
-            </a:r>
-          </a:p>
-        </p:txBody>
-      </p:sp>
-      <p:sp>
-        <p:nvSpPr>
-          <p:cNvPr id="12" name="Rounded Rectangle 11"/>
+              <a:t>The board's biggest model-vs-market fight — the machine never bought the move from −17.5 to −21.5.</a:t>
+            </a:r>
+          </a:p>
+        </p:txBody>
+      </p:sp>
+      <p:sp>
+        <p:nvSpPr>
+          <p:cNvPr id="9" name="Rounded Rectangle 8"/>
           <p:cNvSpPr/>
           <p:nvPr/>
         </p:nvSpPr>
         <p:spPr>
           <a:xfrm>
-            <a:off x="6263640" y="1463040"/>
-            <a:ext cx="5074920" cy="4480560"/>
+            <a:off x="6263640" y="1554480"/>
+            <a:ext cx="5074920" cy="2834640"/>
           </a:xfrm>
           <a:prstGeom prst="roundRect">
             <a:avLst/>
@@ -11992,35 +11887,140 @@
       </p:sp>
       <p:sp>
         <p:nvSpPr>
+          <p:cNvPr id="10" name="TextBox 9"/>
+          <p:cNvSpPr txBox="1"/>
+          <p:nvPr/>
+        </p:nvSpPr>
+        <p:spPr>
+          <a:xfrm>
+            <a:off x="6537960" y="1783080"/>
+            <a:ext cx="4572000" cy="274320"/>
+          </a:xfrm>
+          <a:prstGeom prst="rect">
+            <a:avLst/>
+          </a:prstGeom>
+          <a:noFill/>
+        </p:spPr>
+        <p:txBody>
+          <a:bodyPr wrap="square" lIns="0" rIns="0" tIns="0" bIns="0">
+            <a:spAutoFit/>
+          </a:bodyPr>
+          <a:lstStyle/>
+          <a:p>
+            <a:pPr algn="l"/>
+            <a:r>
+              <a:rPr sz="1200" b="1" i="0">
+                <a:solidFill>
+                  <a:srgbClr val="F47321"/>
+                </a:solidFill>
+                <a:latin typeface="Arial"/>
+              </a:rPr>
+              <a:t>GIANT KILLER — dog vs an AP top-25 team</a:t>
+            </a:r>
+          </a:p>
+        </p:txBody>
+      </p:sp>
+      <p:sp>
+        <p:nvSpPr>
+          <p:cNvPr id="11" name="TextBox 10"/>
+          <p:cNvSpPr txBox="1"/>
+          <p:nvPr/>
+        </p:nvSpPr>
+        <p:spPr>
+          <a:xfrm>
+            <a:off x="6537960" y="2240280"/>
+            <a:ext cx="4572000" cy="457200"/>
+          </a:xfrm>
+          <a:prstGeom prst="rect">
+            <a:avLst/>
+          </a:prstGeom>
+          <a:noFill/>
+        </p:spPr>
+        <p:txBody>
+          <a:bodyPr wrap="square" lIns="0" rIns="0" tIns="0" bIns="0">
+            <a:spAutoFit/>
+          </a:bodyPr>
+          <a:lstStyle/>
+          <a:p>
+            <a:pPr algn="l"/>
+            <a:r>
+              <a:rPr sz="1700" b="1" i="0">
+                <a:solidFill>
+                  <a:srgbClr val="F47321"/>
+                </a:solidFill>
+                <a:latin typeface="Arial"/>
+              </a:rPr>
+              <a:t>★ Washington State +23.5 at #17 Washington</a:t>
+            </a:r>
+          </a:p>
+        </p:txBody>
+      </p:sp>
+      <p:sp>
+        <p:nvSpPr>
+          <p:cNvPr id="12" name="TextBox 11"/>
+          <p:cNvSpPr txBox="1"/>
+          <p:nvPr/>
+        </p:nvSpPr>
+        <p:spPr>
+          <a:xfrm>
+            <a:off x="6537960" y="2788920"/>
+            <a:ext cx="4572000" cy="274320"/>
+          </a:xfrm>
+          <a:prstGeom prst="rect">
+            <a:avLst/>
+          </a:prstGeom>
+          <a:noFill/>
+        </p:spPr>
+        <p:txBody>
+          <a:bodyPr wrap="square" lIns="0" rIns="0" tIns="0" bIns="0">
+            <a:spAutoFit/>
+          </a:bodyPr>
+          <a:lstStyle/>
+          <a:p>
+            <a:pPr algn="l"/>
+            <a:r>
+              <a:rPr sz="1050" b="0" i="0">
+                <a:solidFill>
+                  <a:srgbClr val="5C6B7E"/>
+                </a:solidFill>
+                <a:latin typeface="Arial"/>
+              </a:rPr>
+              <a:t>model 18% to win outright · market 7% · expected pts 4.3</a:t>
+            </a:r>
+          </a:p>
+        </p:txBody>
+      </p:sp>
+      <p:sp>
+        <p:nvSpPr>
           <p:cNvPr id="13" name="TextBox 12"/>
           <p:cNvSpPr txBox="1"/>
           <p:nvPr/>
         </p:nvSpPr>
         <p:spPr>
           <a:xfrm>
-            <a:off x="6537960" y="1645920"/>
-            <a:ext cx="4572000" cy="274320"/>
-          </a:xfrm>
-          <a:prstGeom prst="rect">
-            <a:avLst/>
-          </a:prstGeom>
-          <a:noFill/>
-        </p:spPr>
-        <p:txBody>
-          <a:bodyPr wrap="square" lIns="0" rIns="0" tIns="0" bIns="0">
-            <a:spAutoFit/>
-          </a:bodyPr>
-          <a:lstStyle/>
-          <a:p>
-            <a:pPr algn="l"/>
-            <a:r>
-              <a:rPr sz="1200" b="1" i="0">
-                <a:solidFill>
-                  <a:srgbClr val="F47321"/>
-                </a:solidFill>
-                <a:latin typeface="Arial"/>
-              </a:rPr>
-              <a:t>GIANT KILLER — dog vs an AP top-25 team</a:t>
+            <a:off x="6537960" y="3246120"/>
+            <a:ext cx="4572000" cy="868680"/>
+          </a:xfrm>
+          <a:prstGeom prst="rect">
+            <a:avLst/>
+          </a:prstGeom>
+          <a:noFill/>
+        </p:spPr>
+        <p:txBody>
+          <a:bodyPr wrap="square" lIns="0" rIns="0" tIns="0" bIns="0">
+            <a:spAutoFit/>
+          </a:bodyPr>
+          <a:lstStyle/>
+          <a:p>
+            <a:pPr algn="l"/>
+            <a:r>
+              <a:rPr sz="1100" b="0" i="1">
+                <a:solidFill>
+                  <a:srgbClr val="16273D"/>
+                </a:solidFill>
+                <a:latin typeface="Arial"/>
+              </a:rPr>
+              <a:t>The Apple Cup — rivalry chaos at a 23-point price, and the machine has the dog at more than double the market's chance.</a:t>
             </a:r>
           </a:p>
         </p:txBody>
@@ -12033,29 +12033,29 @@
         </p:nvSpPr>
         <p:spPr>
           <a:xfrm>
-            <a:off x="6537960" y="2057400"/>
-            <a:ext cx="4572000" cy="320040"/>
-          </a:xfrm>
-          <a:prstGeom prst="rect">
-            <a:avLst/>
-          </a:prstGeom>
-          <a:noFill/>
-        </p:spPr>
-        <p:txBody>
-          <a:bodyPr wrap="square" lIns="0" rIns="0" tIns="0" bIns="0">
-            <a:spAutoFit/>
-          </a:bodyPr>
-          <a:lstStyle/>
-          <a:p>
-            <a:pPr algn="l"/>
-            <a:r>
-              <a:rPr sz="1300" b="1" i="0">
-                <a:solidFill>
-                  <a:srgbClr val="F47321"/>
-                </a:solidFill>
-                <a:latin typeface="Arial"/>
-              </a:rPr>
-              <a:t>★ Washington State +23.5 at #17 Washington</a:t>
+            <a:off x="822960" y="4800600"/>
+            <a:ext cx="10515600" cy="457200"/>
+          </a:xfrm>
+          <a:prstGeom prst="rect">
+            <a:avLst/>
+          </a:prstGeom>
+          <a:noFill/>
+        </p:spPr>
+        <p:txBody>
+          <a:bodyPr wrap="square" lIns="0" rIns="0" tIns="0" bIns="0">
+            <a:spAutoFit/>
+          </a:bodyPr>
+          <a:lstStyle/>
+          <a:p>
+            <a:pPr algn="l"/>
+            <a:r>
+              <a:rPr sz="1000" b="0" i="1">
+                <a:solidFill>
+                  <a:srgbClr val="5C6B7E"/>
+                </a:solidFill>
+                <a:latin typeface="Arial"/>
+              </a:rPr>
+              <a:t>Honesty: model probs ride preseason priors and σ 17.9 — the biggest model-vs-market gaps sit exactly where the favorite-longshot bias lives. A points game between hosts, not a betting card.</a:t>
             </a:r>
           </a:p>
         </p:txBody>
@@ -12063,251 +12063,6 @@
       <p:sp>
         <p:nvSpPr>
           <p:cNvPr id="15" name="TextBox 14"/>
-          <p:cNvSpPr txBox="1"/>
-          <p:nvPr/>
-        </p:nvSpPr>
-        <p:spPr>
-          <a:xfrm>
-            <a:off x="6537960" y="2386584"/>
-            <a:ext cx="4572000" cy="274320"/>
-          </a:xfrm>
-          <a:prstGeom prst="rect">
-            <a:avLst/>
-          </a:prstGeom>
-          <a:noFill/>
-        </p:spPr>
-        <p:txBody>
-          <a:bodyPr wrap="square" lIns="0" rIns="0" tIns="0" bIns="0">
-            <a:spAutoFit/>
-          </a:bodyPr>
-          <a:lstStyle/>
-          <a:p>
-            <a:pPr algn="l"/>
-            <a:r>
-              <a:rPr sz="1000" b="0" i="0">
-                <a:solidFill>
-                  <a:srgbClr val="5C6B7E"/>
-                </a:solidFill>
-                <a:latin typeface="Arial"/>
-              </a:rPr>
-              <a:t>model 18% · market 7% · expected pts 4.3</a:t>
-            </a:r>
-          </a:p>
-        </p:txBody>
-      </p:sp>
-      <p:sp>
-        <p:nvSpPr>
-          <p:cNvPr id="16" name="TextBox 15"/>
-          <p:cNvSpPr txBox="1"/>
-          <p:nvPr/>
-        </p:nvSpPr>
-        <p:spPr>
-          <a:xfrm>
-            <a:off x="6537960" y="2926080"/>
-            <a:ext cx="4572000" cy="320040"/>
-          </a:xfrm>
-          <a:prstGeom prst="rect">
-            <a:avLst/>
-          </a:prstGeom>
-          <a:noFill/>
-        </p:spPr>
-        <p:txBody>
-          <a:bodyPr wrap="square" lIns="0" rIns="0" tIns="0" bIns="0">
-            <a:spAutoFit/>
-          </a:bodyPr>
-          <a:lstStyle/>
-          <a:p>
-            <a:pPr algn="l"/>
-            <a:r>
-              <a:rPr sz="1200" b="1" i="0">
-                <a:solidFill>
-                  <a:srgbClr val="16273D"/>
-                </a:solidFill>
-                <a:latin typeface="Arial"/>
-              </a:rPr>
-              <a:t>Oregon State +20.5 at #23 Houston</a:t>
-            </a:r>
-          </a:p>
-        </p:txBody>
-      </p:sp>
-      <p:sp>
-        <p:nvSpPr>
-          <p:cNvPr id="17" name="TextBox 16"/>
-          <p:cNvSpPr txBox="1"/>
-          <p:nvPr/>
-        </p:nvSpPr>
-        <p:spPr>
-          <a:xfrm>
-            <a:off x="6537960" y="3255264"/>
-            <a:ext cx="4572000" cy="274320"/>
-          </a:xfrm>
-          <a:prstGeom prst="rect">
-            <a:avLst/>
-          </a:prstGeom>
-          <a:noFill/>
-        </p:spPr>
-        <p:txBody>
-          <a:bodyPr wrap="square" lIns="0" rIns="0" tIns="0" bIns="0">
-            <a:spAutoFit/>
-          </a:bodyPr>
-          <a:lstStyle/>
-          <a:p>
-            <a:pPr algn="l"/>
-            <a:r>
-              <a:rPr sz="1000" b="0" i="0">
-                <a:solidFill>
-                  <a:srgbClr val="5C6B7E"/>
-                </a:solidFill>
-                <a:latin typeface="Arial"/>
-              </a:rPr>
-              <a:t>model 17% · market 9% · expected pts 3.4</a:t>
-            </a:r>
-          </a:p>
-        </p:txBody>
-      </p:sp>
-      <p:sp>
-        <p:nvSpPr>
-          <p:cNvPr id="18" name="TextBox 17"/>
-          <p:cNvSpPr txBox="1"/>
-          <p:nvPr/>
-        </p:nvSpPr>
-        <p:spPr>
-          <a:xfrm>
-            <a:off x="6537960" y="3794760"/>
-            <a:ext cx="4572000" cy="320040"/>
-          </a:xfrm>
-          <a:prstGeom prst="rect">
-            <a:avLst/>
-          </a:prstGeom>
-          <a:noFill/>
-        </p:spPr>
-        <p:txBody>
-          <a:bodyPr wrap="square" lIns="0" rIns="0" tIns="0" bIns="0">
-            <a:spAutoFit/>
-          </a:bodyPr>
-          <a:lstStyle/>
-          <a:p>
-            <a:pPr algn="l"/>
-            <a:r>
-              <a:rPr sz="1200" b="1" i="0">
-                <a:solidFill>
-                  <a:srgbClr val="16273D"/>
-                </a:solidFill>
-                <a:latin typeface="Arial"/>
-              </a:rPr>
-              <a:t>Clemson +10.5 at #11 LSU</a:t>
-            </a:r>
-          </a:p>
-        </p:txBody>
-      </p:sp>
-      <p:sp>
-        <p:nvSpPr>
-          <p:cNvPr id="19" name="TextBox 18"/>
-          <p:cNvSpPr txBox="1"/>
-          <p:nvPr/>
-        </p:nvSpPr>
-        <p:spPr>
-          <a:xfrm>
-            <a:off x="6537960" y="4123944"/>
-            <a:ext cx="4572000" cy="274320"/>
-          </a:xfrm>
-          <a:prstGeom prst="rect">
-            <a:avLst/>
-          </a:prstGeom>
-          <a:noFill/>
-        </p:spPr>
-        <p:txBody>
-          <a:bodyPr wrap="square" lIns="0" rIns="0" tIns="0" bIns="0">
-            <a:spAutoFit/>
-          </a:bodyPr>
-          <a:lstStyle/>
-          <a:p>
-            <a:pPr algn="l"/>
-            <a:r>
-              <a:rPr sz="1000" b="0" i="0">
-                <a:solidFill>
-                  <a:srgbClr val="5C6B7E"/>
-                </a:solidFill>
-                <a:latin typeface="Arial"/>
-              </a:rPr>
-              <a:t>model 30% · market 24% · expected pts 3.2</a:t>
-            </a:r>
-          </a:p>
-        </p:txBody>
-      </p:sp>
-      <p:sp>
-        <p:nvSpPr>
-          <p:cNvPr id="20" name="TextBox 19"/>
-          <p:cNvSpPr txBox="1"/>
-          <p:nvPr/>
-        </p:nvSpPr>
-        <p:spPr>
-          <a:xfrm>
-            <a:off x="6537960" y="4892040"/>
-            <a:ext cx="4572000" cy="822960"/>
-          </a:xfrm>
-          <a:prstGeom prst="rect">
-            <a:avLst/>
-          </a:prstGeom>
-          <a:noFill/>
-        </p:spPr>
-        <p:txBody>
-          <a:bodyPr wrap="square" lIns="0" rIns="0" tIns="0" bIns="0">
-            <a:spAutoFit/>
-          </a:bodyPr>
-          <a:lstStyle/>
-          <a:p>
-            <a:pPr algn="l"/>
-            <a:r>
-              <a:rPr sz="1050" b="0" i="1">
-                <a:solidFill>
-                  <a:srgbClr val="16273D"/>
-                </a:solidFill>
-                <a:latin typeface="Arial"/>
-              </a:rPr>
-              <a:t>Most likely ranked upset: Florida State +3 vs #19 SMU — 52% (low points, high cash rate)</a:t>
-            </a:r>
-          </a:p>
-        </p:txBody>
-      </p:sp>
-      <p:sp>
-        <p:nvSpPr>
-          <p:cNvPr id="21" name="TextBox 20"/>
-          <p:cNvSpPr txBox="1"/>
-          <p:nvPr/>
-        </p:nvSpPr>
-        <p:spPr>
-          <a:xfrm>
-            <a:off x="822960" y="6126480"/>
-            <a:ext cx="10515600" cy="457200"/>
-          </a:xfrm>
-          <a:prstGeom prst="rect">
-            <a:avLst/>
-          </a:prstGeom>
-          <a:noFill/>
-        </p:spPr>
-        <p:txBody>
-          <a:bodyPr wrap="square" lIns="0" rIns="0" tIns="0" bIns="0">
-            <a:spAutoFit/>
-          </a:bodyPr>
-          <a:lstStyle/>
-          <a:p>
-            <a:pPr algn="l"/>
-            <a:r>
-              <a:rPr sz="1000" b="0" i="1">
-                <a:solidFill>
-                  <a:srgbClr val="5C6B7E"/>
-                </a:solidFill>
-                <a:latin typeface="Arial"/>
-              </a:rPr>
-              <a:t>Honesty: model probs ride preseason priors and σ 17.9 — the biggest model-vs-market gaps sit exactly where the favorite-longshot bias lives. A points game between hosts, not a betting card.</a:t>
-            </a:r>
-          </a:p>
-        </p:txBody>
-      </p:sp>
-      <p:sp>
-        <p:nvSpPr>
-          <p:cNvPr id="22" name="TextBox 21"/>
           <p:cNvSpPr txBox="1"/>
           <p:nvPr/>
         </p:nvSpPr>

</xml_diff>

<commit_message>
Final slide: basic predictions + superdog picks with final odds, no movement
Standalone superdog slide retired; the closer shows the five projected
scores with the current market line and an orange band with the two
superdog picks and their moneylines. Movement strips removed from the
closer (they stay on the game slides and in the ledger).

Co-Authored-By: Claude Fable 5 <noreply@anthropic.com>
</commit_message>
<xml_diff>
--- a/decks/2026_Week1_Episode2.pptx
+++ b/decks/2026_Week1_Episode2.pptx
@@ -23,7 +23,6 @@
     <p:sldId id="271" r:id="rId22"/>
     <p:sldId id="272" r:id="rId23"/>
     <p:sldId id="273" r:id="rId24"/>
-    <p:sldId id="274" r:id="rId25"/>
   </p:sldIdLst>
   <p:sldSz cx="12191695" cy="6858000" type="screen4x3"/>
   <p:notesSz cx="6858000" cy="9144000"/>
@@ -11575,540 +11574,6 @@
     <p:bg>
       <p:bgPr>
         <a:solidFill>
-          <a:srgbClr val="FFFFFF"/>
-        </a:solidFill>
-        <a:effectLst/>
-      </p:bgPr>
-    </p:bg>
-    <p:spTree>
-      <p:nvGrpSpPr>
-        <p:cNvPr id="1" name=""/>
-        <p:cNvGrpSpPr/>
-        <p:nvPr/>
-      </p:nvGrpSpPr>
-      <p:grpSpPr/>
-      <p:sp>
-        <p:nvSpPr>
-          <p:cNvPr id="2" name="TextBox 1"/>
-          <p:cNvSpPr txBox="1"/>
-          <p:nvPr/>
-        </p:nvSpPr>
-        <p:spPr>
-          <a:xfrm>
-            <a:off x="822960" y="457200"/>
-            <a:ext cx="10515600" cy="502920"/>
-          </a:xfrm>
-          <a:prstGeom prst="rect">
-            <a:avLst/>
-          </a:prstGeom>
-          <a:noFill/>
-        </p:spPr>
-        <p:txBody>
-          <a:bodyPr wrap="square" lIns="0" rIns="0" tIns="0" bIns="0">
-            <a:spAutoFit/>
-          </a:bodyPr>
-          <a:lstStyle/>
-          <a:p>
-            <a:pPr algn="l"/>
-            <a:r>
-              <a:rPr sz="3000" b="1" i="0">
-                <a:solidFill>
-                  <a:srgbClr val="0A2851"/>
-                </a:solidFill>
-                <a:latin typeface="Arial"/>
-              </a:rPr>
-              <a:t>Superdog Picks</a:t>
-            </a:r>
-          </a:p>
-        </p:txBody>
-      </p:sp>
-      <p:sp>
-        <p:nvSpPr>
-          <p:cNvPr id="3" name="TextBox 2"/>
-          <p:cNvSpPr txBox="1"/>
-          <p:nvPr/>
-        </p:nvSpPr>
-        <p:spPr>
-          <a:xfrm>
-            <a:off x="822960" y="987552"/>
-            <a:ext cx="10515600" cy="274320"/>
-          </a:xfrm>
-          <a:prstGeom prst="rect">
-            <a:avLst/>
-          </a:prstGeom>
-          <a:noFill/>
-        </p:spPr>
-        <p:txBody>
-          <a:bodyPr wrap="square" lIns="0" rIns="0" tIns="0" bIns="0">
-            <a:spAutoFit/>
-          </a:bodyPr>
-          <a:lstStyle/>
-          <a:p>
-            <a:pPr algn="l"/>
-            <a:r>
-              <a:rPr sz="1100" b="0" i="1">
-                <a:solidFill>
-                  <a:srgbClr val="5C6B7E"/>
-                </a:solidFill>
-                <a:latin typeface="Arial"/>
-              </a:rPr>
-              <a:t>Pick a dog to WIN OUTRIGHT — points = the spread · machine board: model win prob vs market, expected points = prob × spread</a:t>
-            </a:r>
-          </a:p>
-        </p:txBody>
-      </p:sp>
-      <p:sp>
-        <p:nvSpPr>
-          <p:cNvPr id="4" name="Rounded Rectangle 3"/>
-          <p:cNvSpPr/>
-          <p:nvPr/>
-        </p:nvSpPr>
-        <p:spPr>
-          <a:xfrm>
-            <a:off x="822960" y="1554480"/>
-            <a:ext cx="5074920" cy="2834640"/>
-          </a:xfrm>
-          <a:prstGeom prst="roundRect">
-            <a:avLst/>
-          </a:prstGeom>
-          <a:solidFill>
-            <a:srgbClr val="EAF0F8"/>
-          </a:solidFill>
-          <a:ln>
-            <a:noFill/>
-          </a:ln>
-          <a:effectLst/>
-        </p:spPr>
-        <p:style>
-          <a:lnRef idx="1">
-            <a:schemeClr val="accent1"/>
-          </a:lnRef>
-          <a:fillRef idx="3">
-            <a:schemeClr val="accent1"/>
-          </a:fillRef>
-          <a:effectRef idx="2">
-            <a:schemeClr val="accent1"/>
-          </a:effectRef>
-          <a:fontRef idx="minor">
-            <a:schemeClr val="lt1"/>
-          </a:fontRef>
-        </p:style>
-        <p:txBody>
-          <a:bodyPr rtlCol="0" anchor="ctr"/>
-          <a:lstStyle/>
-          <a:p>
-            <a:pPr algn="ctr"/>
-          </a:p>
-        </p:txBody>
-      </p:sp>
-      <p:sp>
-        <p:nvSpPr>
-          <p:cNvPr id="5" name="TextBox 4"/>
-          <p:cNvSpPr txBox="1"/>
-          <p:nvPr/>
-        </p:nvSpPr>
-        <p:spPr>
-          <a:xfrm>
-            <a:off x="1097280" y="1783080"/>
-            <a:ext cx="4572000" cy="274320"/>
-          </a:xfrm>
-          <a:prstGeom prst="rect">
-            <a:avLst/>
-          </a:prstGeom>
-          <a:noFill/>
-        </p:spPr>
-        <p:txBody>
-          <a:bodyPr wrap="square" lIns="0" rIns="0" tIns="0" bIns="0">
-            <a:spAutoFit/>
-          </a:bodyPr>
-          <a:lstStyle/>
-          <a:p>
-            <a:pPr algn="l"/>
-            <a:r>
-              <a:rPr sz="1200" b="1" i="0">
-                <a:solidFill>
-                  <a:srgbClr val="F47321"/>
-                </a:solidFill>
-                <a:latin typeface="Arial"/>
-              </a:rPr>
-              <a:t>ANY GAME</a:t>
-            </a:r>
-          </a:p>
-        </p:txBody>
-      </p:sp>
-      <p:sp>
-        <p:nvSpPr>
-          <p:cNvPr id="6" name="TextBox 5"/>
-          <p:cNvSpPr txBox="1"/>
-          <p:nvPr/>
-        </p:nvSpPr>
-        <p:spPr>
-          <a:xfrm>
-            <a:off x="1097280" y="2240280"/>
-            <a:ext cx="4572000" cy="457200"/>
-          </a:xfrm>
-          <a:prstGeom prst="rect">
-            <a:avLst/>
-          </a:prstGeom>
-          <a:noFill/>
-        </p:spPr>
-        <p:txBody>
-          <a:bodyPr wrap="square" lIns="0" rIns="0" tIns="0" bIns="0">
-            <a:spAutoFit/>
-          </a:bodyPr>
-          <a:lstStyle/>
-          <a:p>
-            <a:pPr algn="l"/>
-            <a:r>
-              <a:rPr sz="1700" b="1" i="0">
-                <a:solidFill>
-                  <a:srgbClr val="F47321"/>
-                </a:solidFill>
-                <a:latin typeface="Arial"/>
-              </a:rPr>
-              <a:t>★ Coastal Carolina +21.5 at West Virginia</a:t>
-            </a:r>
-          </a:p>
-        </p:txBody>
-      </p:sp>
-      <p:sp>
-        <p:nvSpPr>
-          <p:cNvPr id="7" name="TextBox 6"/>
-          <p:cNvSpPr txBox="1"/>
-          <p:nvPr/>
-        </p:nvSpPr>
-        <p:spPr>
-          <a:xfrm>
-            <a:off x="1097280" y="2788920"/>
-            <a:ext cx="4572000" cy="274320"/>
-          </a:xfrm>
-          <a:prstGeom prst="rect">
-            <a:avLst/>
-          </a:prstGeom>
-          <a:noFill/>
-        </p:spPr>
-        <p:txBody>
-          <a:bodyPr wrap="square" lIns="0" rIns="0" tIns="0" bIns="0">
-            <a:spAutoFit/>
-          </a:bodyPr>
-          <a:lstStyle/>
-          <a:p>
-            <a:pPr algn="l"/>
-            <a:r>
-              <a:rPr sz="1050" b="0" i="0">
-                <a:solidFill>
-                  <a:srgbClr val="5C6B7E"/>
-                </a:solidFill>
-                <a:latin typeface="Arial"/>
-              </a:rPr>
-              <a:t>model 21% to win outright · market 9% · expected pts 4.4</a:t>
-            </a:r>
-          </a:p>
-        </p:txBody>
-      </p:sp>
-      <p:sp>
-        <p:nvSpPr>
-          <p:cNvPr id="8" name="TextBox 7"/>
-          <p:cNvSpPr txBox="1"/>
-          <p:nvPr/>
-        </p:nvSpPr>
-        <p:spPr>
-          <a:xfrm>
-            <a:off x="1097280" y="3246120"/>
-            <a:ext cx="4572000" cy="868680"/>
-          </a:xfrm>
-          <a:prstGeom prst="rect">
-            <a:avLst/>
-          </a:prstGeom>
-          <a:noFill/>
-        </p:spPr>
-        <p:txBody>
-          <a:bodyPr wrap="square" lIns="0" rIns="0" tIns="0" bIns="0">
-            <a:spAutoFit/>
-          </a:bodyPr>
-          <a:lstStyle/>
-          <a:p>
-            <a:pPr algn="l"/>
-            <a:r>
-              <a:rPr sz="1100" b="0" i="1">
-                <a:solidFill>
-                  <a:srgbClr val="16273D"/>
-                </a:solidFill>
-                <a:latin typeface="Arial"/>
-              </a:rPr>
-              <a:t>The board's biggest model-vs-market fight — the machine never bought the move from −17.5 to −21.5.</a:t>
-            </a:r>
-          </a:p>
-        </p:txBody>
-      </p:sp>
-      <p:sp>
-        <p:nvSpPr>
-          <p:cNvPr id="9" name="Rounded Rectangle 8"/>
-          <p:cNvSpPr/>
-          <p:nvPr/>
-        </p:nvSpPr>
-        <p:spPr>
-          <a:xfrm>
-            <a:off x="6263640" y="1554480"/>
-            <a:ext cx="5074920" cy="2834640"/>
-          </a:xfrm>
-          <a:prstGeom prst="roundRect">
-            <a:avLst/>
-          </a:prstGeom>
-          <a:solidFill>
-            <a:srgbClr val="EAF0F8"/>
-          </a:solidFill>
-          <a:ln>
-            <a:noFill/>
-          </a:ln>
-          <a:effectLst/>
-        </p:spPr>
-        <p:style>
-          <a:lnRef idx="1">
-            <a:schemeClr val="accent1"/>
-          </a:lnRef>
-          <a:fillRef idx="3">
-            <a:schemeClr val="accent1"/>
-          </a:fillRef>
-          <a:effectRef idx="2">
-            <a:schemeClr val="accent1"/>
-          </a:effectRef>
-          <a:fontRef idx="minor">
-            <a:schemeClr val="lt1"/>
-          </a:fontRef>
-        </p:style>
-        <p:txBody>
-          <a:bodyPr rtlCol="0" anchor="ctr"/>
-          <a:lstStyle/>
-          <a:p>
-            <a:pPr algn="ctr"/>
-          </a:p>
-        </p:txBody>
-      </p:sp>
-      <p:sp>
-        <p:nvSpPr>
-          <p:cNvPr id="10" name="TextBox 9"/>
-          <p:cNvSpPr txBox="1"/>
-          <p:nvPr/>
-        </p:nvSpPr>
-        <p:spPr>
-          <a:xfrm>
-            <a:off x="6537960" y="1783080"/>
-            <a:ext cx="4572000" cy="274320"/>
-          </a:xfrm>
-          <a:prstGeom prst="rect">
-            <a:avLst/>
-          </a:prstGeom>
-          <a:noFill/>
-        </p:spPr>
-        <p:txBody>
-          <a:bodyPr wrap="square" lIns="0" rIns="0" tIns="0" bIns="0">
-            <a:spAutoFit/>
-          </a:bodyPr>
-          <a:lstStyle/>
-          <a:p>
-            <a:pPr algn="l"/>
-            <a:r>
-              <a:rPr sz="1200" b="1" i="0">
-                <a:solidFill>
-                  <a:srgbClr val="F47321"/>
-                </a:solidFill>
-                <a:latin typeface="Arial"/>
-              </a:rPr>
-              <a:t>GIANT KILLER — dog vs an AP top-25 team</a:t>
-            </a:r>
-          </a:p>
-        </p:txBody>
-      </p:sp>
-      <p:sp>
-        <p:nvSpPr>
-          <p:cNvPr id="11" name="TextBox 10"/>
-          <p:cNvSpPr txBox="1"/>
-          <p:nvPr/>
-        </p:nvSpPr>
-        <p:spPr>
-          <a:xfrm>
-            <a:off x="6537960" y="2240280"/>
-            <a:ext cx="4572000" cy="457200"/>
-          </a:xfrm>
-          <a:prstGeom prst="rect">
-            <a:avLst/>
-          </a:prstGeom>
-          <a:noFill/>
-        </p:spPr>
-        <p:txBody>
-          <a:bodyPr wrap="square" lIns="0" rIns="0" tIns="0" bIns="0">
-            <a:spAutoFit/>
-          </a:bodyPr>
-          <a:lstStyle/>
-          <a:p>
-            <a:pPr algn="l"/>
-            <a:r>
-              <a:rPr sz="1700" b="1" i="0">
-                <a:solidFill>
-                  <a:srgbClr val="F47321"/>
-                </a:solidFill>
-                <a:latin typeface="Arial"/>
-              </a:rPr>
-              <a:t>★ Washington State +23.5 at #17 Washington</a:t>
-            </a:r>
-          </a:p>
-        </p:txBody>
-      </p:sp>
-      <p:sp>
-        <p:nvSpPr>
-          <p:cNvPr id="12" name="TextBox 11"/>
-          <p:cNvSpPr txBox="1"/>
-          <p:nvPr/>
-        </p:nvSpPr>
-        <p:spPr>
-          <a:xfrm>
-            <a:off x="6537960" y="2788920"/>
-            <a:ext cx="4572000" cy="274320"/>
-          </a:xfrm>
-          <a:prstGeom prst="rect">
-            <a:avLst/>
-          </a:prstGeom>
-          <a:noFill/>
-        </p:spPr>
-        <p:txBody>
-          <a:bodyPr wrap="square" lIns="0" rIns="0" tIns="0" bIns="0">
-            <a:spAutoFit/>
-          </a:bodyPr>
-          <a:lstStyle/>
-          <a:p>
-            <a:pPr algn="l"/>
-            <a:r>
-              <a:rPr sz="1050" b="0" i="0">
-                <a:solidFill>
-                  <a:srgbClr val="5C6B7E"/>
-                </a:solidFill>
-                <a:latin typeface="Arial"/>
-              </a:rPr>
-              <a:t>model 18% to win outright · market 7% · expected pts 4.3</a:t>
-            </a:r>
-          </a:p>
-        </p:txBody>
-      </p:sp>
-      <p:sp>
-        <p:nvSpPr>
-          <p:cNvPr id="13" name="TextBox 12"/>
-          <p:cNvSpPr txBox="1"/>
-          <p:nvPr/>
-        </p:nvSpPr>
-        <p:spPr>
-          <a:xfrm>
-            <a:off x="6537960" y="3246120"/>
-            <a:ext cx="4572000" cy="868680"/>
-          </a:xfrm>
-          <a:prstGeom prst="rect">
-            <a:avLst/>
-          </a:prstGeom>
-          <a:noFill/>
-        </p:spPr>
-        <p:txBody>
-          <a:bodyPr wrap="square" lIns="0" rIns="0" tIns="0" bIns="0">
-            <a:spAutoFit/>
-          </a:bodyPr>
-          <a:lstStyle/>
-          <a:p>
-            <a:pPr algn="l"/>
-            <a:r>
-              <a:rPr sz="1100" b="0" i="1">
-                <a:solidFill>
-                  <a:srgbClr val="16273D"/>
-                </a:solidFill>
-                <a:latin typeface="Arial"/>
-              </a:rPr>
-              <a:t>The Apple Cup — rivalry chaos at a 23-point price, and the machine has the dog at more than double the market's chance.</a:t>
-            </a:r>
-          </a:p>
-        </p:txBody>
-      </p:sp>
-      <p:sp>
-        <p:nvSpPr>
-          <p:cNvPr id="14" name="TextBox 13"/>
-          <p:cNvSpPr txBox="1"/>
-          <p:nvPr/>
-        </p:nvSpPr>
-        <p:spPr>
-          <a:xfrm>
-            <a:off x="822960" y="4800600"/>
-            <a:ext cx="10515600" cy="457200"/>
-          </a:xfrm>
-          <a:prstGeom prst="rect">
-            <a:avLst/>
-          </a:prstGeom>
-          <a:noFill/>
-        </p:spPr>
-        <p:txBody>
-          <a:bodyPr wrap="square" lIns="0" rIns="0" tIns="0" bIns="0">
-            <a:spAutoFit/>
-          </a:bodyPr>
-          <a:lstStyle/>
-          <a:p>
-            <a:pPr algn="l"/>
-            <a:r>
-              <a:rPr sz="1000" b="0" i="1">
-                <a:solidFill>
-                  <a:srgbClr val="5C6B7E"/>
-                </a:solidFill>
-                <a:latin typeface="Arial"/>
-              </a:rPr>
-              <a:t>Honesty: model probs ride preseason priors and σ 17.9 — the biggest model-vs-market gaps sit exactly where the favorite-longshot bias lives. A points game between hosts, not a betting card.</a:t>
-            </a:r>
-          </a:p>
-        </p:txBody>
-      </p:sp>
-      <p:sp>
-        <p:nvSpPr>
-          <p:cNvPr id="15" name="TextBox 14"/>
-          <p:cNvSpPr txBox="1"/>
-          <p:nvPr/>
-        </p:nvSpPr>
-        <p:spPr>
-          <a:xfrm>
-            <a:off x="822960" y="6519672"/>
-            <a:ext cx="10515600" cy="274320"/>
-          </a:xfrm>
-          <a:prstGeom prst="rect">
-            <a:avLst/>
-          </a:prstGeom>
-          <a:noFill/>
-        </p:spPr>
-        <p:txBody>
-          <a:bodyPr wrap="square" lIns="0" rIns="0" tIns="0" bIns="0">
-            <a:spAutoFit/>
-          </a:bodyPr>
-          <a:lstStyle/>
-          <a:p>
-            <a:pPr algn="l"/>
-            <a:r>
-              <a:rPr sz="900" b="0" i="0">
-                <a:solidFill>
-                  <a:srgbClr val="5C6B7E"/>
-                </a:solidFill>
-                <a:latin typeface="Arial"/>
-              </a:rPr>
-              <a:t>EP 2 · WEEK 1 · SUPERDOG PICKS</a:t>
-            </a:r>
-          </a:p>
-        </p:txBody>
-      </p:sp>
-    </p:spTree>
-  </p:cSld>
-  <p:clrMapOvr>
-    <a:masterClrMapping/>
-  </p:clrMapOvr>
-</p:sld>
-</file>
-
-<file path=ppt/slides/slide19.xml><?xml version="1.0" encoding="utf-8"?>
-<p:sld xmlns:a="http://schemas.openxmlformats.org/drawingml/2006/main" xmlns:p="http://schemas.openxmlformats.org/presentationml/2006/main" xmlns:r="http://schemas.openxmlformats.org/officeDocument/2006/relationships">
-  <p:cSld>
-    <p:bg>
-      <p:bgPr>
-        <a:solidFill>
           <a:srgbClr val="0A2851"/>
         </a:solidFill>
         <a:effectLst/>
@@ -12129,7 +11594,7 @@
         </p:nvSpPr>
         <p:spPr>
           <a:xfrm>
-            <a:off x="822960" y="640080"/>
+            <a:off x="822960" y="502920"/>
             <a:ext cx="10515600" cy="411480"/>
           </a:xfrm>
           <a:prstGeom prst="rect">
@@ -12151,7 +11616,7 @@
                 </a:solidFill>
                 <a:latin typeface="Arial"/>
               </a:rPr>
-              <a:t>EPISODE 2 · THE CARD · OUR PREDICTIONS</a:t>
+              <a:t>EPISODE 2 · THE CARD</a:t>
             </a:r>
           </a:p>
         </p:txBody>
@@ -12164,8 +11629,8 @@
         </p:nvSpPr>
         <p:spPr>
           <a:xfrm>
-            <a:off x="822960" y="1005840"/>
-            <a:ext cx="10515600" cy="822960"/>
+            <a:off x="822960" y="868680"/>
+            <a:ext cx="10515600" cy="731520"/>
           </a:xfrm>
           <a:prstGeom prst="rect">
             <a:avLst/>
@@ -12186,7 +11651,7 @@
                 </a:solidFill>
                 <a:latin typeface="Arial"/>
               </a:rPr>
-              <a:t>Where the machine stands</a:t>
+              <a:t>Our predictions</a:t>
             </a:r>
           </a:p>
         </p:txBody>
@@ -12199,8 +11664,8 @@
         </p:nvSpPr>
         <p:spPr>
           <a:xfrm>
-            <a:off x="822960" y="1965960"/>
-            <a:ext cx="10515600" cy="768096"/>
+            <a:off x="822960" y="1783080"/>
+            <a:ext cx="10515600" cy="658368"/>
           </a:xfrm>
           <a:prstGeom prst="roundRect">
             <a:avLst/>
@@ -12243,8 +11708,8 @@
         </p:nvSpPr>
         <p:spPr>
           <a:xfrm>
-            <a:off x="1005840" y="2075688"/>
-            <a:ext cx="548640" cy="548640"/>
+            <a:off x="1005840" y="1874519"/>
+            <a:ext cx="475488" cy="475488"/>
           </a:xfrm>
           <a:prstGeom prst="ellipse">
             <a:avLst/>
@@ -12295,8 +11760,8 @@
         </p:blipFill>
         <p:spPr>
           <a:xfrm>
-            <a:off x="1060704" y="2130552"/>
-            <a:ext cx="438912" cy="438912"/>
+            <a:off x="1053388" y="1922068"/>
+            <a:ext cx="380390" cy="380390"/>
           </a:xfrm>
           <a:prstGeom prst="rect">
             <a:avLst/>
@@ -12311,8 +11776,8 @@
         </p:nvSpPr>
         <p:spPr>
           <a:xfrm>
-            <a:off x="1691640" y="2075688"/>
-            <a:ext cx="548640" cy="548640"/>
+            <a:off x="1600200" y="1874519"/>
+            <a:ext cx="475488" cy="475488"/>
           </a:xfrm>
           <a:prstGeom prst="ellipse">
             <a:avLst/>
@@ -12363,8 +11828,8 @@
         </p:blipFill>
         <p:spPr>
           <a:xfrm>
-            <a:off x="1746504" y="2130552"/>
-            <a:ext cx="438912" cy="438912"/>
+            <a:off x="1647748" y="1922068"/>
+            <a:ext cx="380390" cy="380390"/>
           </a:xfrm>
           <a:prstGeom prst="rect">
             <a:avLst/>
@@ -12379,7 +11844,7 @@
         </p:nvSpPr>
         <p:spPr>
           <a:xfrm>
-            <a:off x="2468880" y="2039112"/>
+            <a:off x="2286000" y="1956816"/>
             <a:ext cx="4937760" cy="365760"/>
           </a:xfrm>
           <a:prstGeom prst="rect">
@@ -12395,7 +11860,7 @@
           <a:p>
             <a:pPr algn="l"/>
             <a:r>
-              <a:rPr sz="1450" b="1" i="0">
+              <a:rPr sz="1400" b="1" i="0">
                 <a:solidFill>
                   <a:srgbClr val="FFFFFF"/>
                 </a:solidFill>
@@ -12414,29 +11879,29 @@
         </p:nvSpPr>
         <p:spPr>
           <a:xfrm>
-            <a:off x="2468880" y="2368296"/>
-            <a:ext cx="4937760" cy="347472"/>
-          </a:xfrm>
-          <a:prstGeom prst="rect">
-            <a:avLst/>
-          </a:prstGeom>
-          <a:noFill/>
-        </p:spPr>
-        <p:txBody>
-          <a:bodyPr wrap="square" lIns="0" rIns="0" tIns="0" bIns="0">
-            <a:spAutoFit/>
-          </a:bodyPr>
-          <a:lstStyle/>
-          <a:p>
-            <a:pPr algn="l"/>
-            <a:r>
-              <a:rPr sz="950" b="0" i="0">
-                <a:solidFill>
-                  <a:srgbClr val="CADCFC"/>
-                </a:solidFill>
-                <a:latin typeface="Arial"/>
-              </a:rPr>
-              <a:t>first-seen –6.5 (Aug 18) → now –7 · CLV -0.5</a:t>
+            <a:off x="6400800" y="1865376"/>
+            <a:ext cx="4754880" cy="384048"/>
+          </a:xfrm>
+          <a:prstGeom prst="rect">
+            <a:avLst/>
+          </a:prstGeom>
+          <a:noFill/>
+        </p:spPr>
+        <p:txBody>
+          <a:bodyPr wrap="square" lIns="0" rIns="0" tIns="0" bIns="0">
+            <a:spAutoFit/>
+          </a:bodyPr>
+          <a:lstStyle/>
+          <a:p>
+            <a:pPr algn="r"/>
+            <a:r>
+              <a:rPr sz="1550" b="1" i="0">
+                <a:solidFill>
+                  <a:srgbClr val="F47321"/>
+                </a:solidFill>
+                <a:latin typeface="Arial"/>
+              </a:rPr>
+              <a:t>Auburn 33 – Baylor 27</a:t>
             </a:r>
           </a:p>
         </p:txBody>
@@ -12449,8 +11914,8 @@
         </p:nvSpPr>
         <p:spPr>
           <a:xfrm>
-            <a:off x="7406640" y="2020824"/>
-            <a:ext cx="3749039" cy="384048"/>
+            <a:off x="6400800" y="2212848"/>
+            <a:ext cx="4754880" cy="228600"/>
           </a:xfrm>
           <a:prstGeom prst="rect">
             <a:avLst/>
@@ -12465,62 +11930,27 @@
           <a:p>
             <a:pPr algn="r"/>
             <a:r>
-              <a:rPr sz="1550" b="1" i="0">
-                <a:solidFill>
-                  <a:srgbClr val="F47321"/>
-                </a:solidFill>
-                <a:latin typeface="Arial"/>
-              </a:rPr>
-              <a:t>Auburn 33 – Baylor 27</a:t>
-            </a:r>
-          </a:p>
-        </p:txBody>
-      </p:sp>
-      <p:sp>
-        <p:nvSpPr>
-          <p:cNvPr id="12" name="TextBox 11"/>
-          <p:cNvSpPr txBox="1"/>
-          <p:nvPr/>
-        </p:nvSpPr>
-        <p:spPr>
-          <a:xfrm>
-            <a:off x="7406640" y="2423160"/>
-            <a:ext cx="3749039" cy="274320"/>
-          </a:xfrm>
-          <a:prstGeom prst="rect">
-            <a:avLst/>
-          </a:prstGeom>
-          <a:noFill/>
-        </p:spPr>
-        <p:txBody>
-          <a:bodyPr wrap="square" lIns="0" rIns="0" tIns="0" bIns="0">
-            <a:spAutoFit/>
-          </a:bodyPr>
-          <a:lstStyle/>
-          <a:p>
-            <a:pPr algn="r"/>
-            <a:r>
               <a:rPr sz="850" b="0" i="0">
                 <a:solidFill>
                   <a:srgbClr val="8FA5C4"/>
                 </a:solidFill>
                 <a:latin typeface="Arial"/>
               </a:rPr>
-              <a:t>machine Auburn –5.5 · market –7 / –7</a:t>
-            </a:r>
-          </a:p>
-        </p:txBody>
-      </p:sp>
-      <p:sp>
-        <p:nvSpPr>
-          <p:cNvPr id="13" name="Rounded Rectangle 12"/>
+              <a:t>market –7 / –7</a:t>
+            </a:r>
+          </a:p>
+        </p:txBody>
+      </p:sp>
+      <p:sp>
+        <p:nvSpPr>
+          <p:cNvPr id="12" name="Rounded Rectangle 11"/>
           <p:cNvSpPr/>
           <p:nvPr/>
         </p:nvSpPr>
         <p:spPr>
           <a:xfrm>
-            <a:off x="822960" y="2807208"/>
-            <a:ext cx="10515600" cy="768096"/>
+            <a:off x="822960" y="2514600"/>
+            <a:ext cx="10515600" cy="658368"/>
           </a:xfrm>
           <a:prstGeom prst="roundRect">
             <a:avLst/>
@@ -12557,14 +11987,14 @@
       </p:sp>
       <p:sp>
         <p:nvSpPr>
-          <p:cNvPr id="14" name="Oval 13"/>
+          <p:cNvPr id="13" name="Oval 12"/>
           <p:cNvSpPr/>
           <p:nvPr/>
         </p:nvSpPr>
         <p:spPr>
           <a:xfrm>
-            <a:off x="1005840" y="2916936"/>
-            <a:ext cx="548640" cy="548640"/>
+            <a:off x="1005840" y="2606040"/>
+            <a:ext cx="475488" cy="475488"/>
           </a:xfrm>
           <a:prstGeom prst="ellipse">
             <a:avLst/>
@@ -12601,7 +12031,7 @@
       </p:sp>
       <p:pic>
         <p:nvPicPr>
-          <p:cNvPr id="15" name="Picture 14" descr="clemson.png"/>
+          <p:cNvPr id="14" name="Picture 13" descr="clemson.png"/>
           <p:cNvPicPr>
             <a:picLocks noChangeAspect="1"/>
           </p:cNvPicPr>
@@ -12615,8 +12045,8 @@
         </p:blipFill>
         <p:spPr>
           <a:xfrm>
-            <a:off x="1060704" y="2971800"/>
-            <a:ext cx="438912" cy="438912"/>
+            <a:off x="1053388" y="2653588"/>
+            <a:ext cx="380390" cy="380390"/>
           </a:xfrm>
           <a:prstGeom prst="rect">
             <a:avLst/>
@@ -12625,14 +12055,14 @@
       </p:pic>
       <p:sp>
         <p:nvSpPr>
-          <p:cNvPr id="16" name="Oval 15"/>
+          <p:cNvPr id="15" name="Oval 14"/>
           <p:cNvSpPr/>
           <p:nvPr/>
         </p:nvSpPr>
         <p:spPr>
           <a:xfrm>
-            <a:off x="1691640" y="2916936"/>
-            <a:ext cx="548640" cy="548640"/>
+            <a:off x="1600200" y="2606040"/>
+            <a:ext cx="475488" cy="475488"/>
           </a:xfrm>
           <a:prstGeom prst="ellipse">
             <a:avLst/>
@@ -12669,7 +12099,7 @@
       </p:sp>
       <p:pic>
         <p:nvPicPr>
-          <p:cNvPr id="17" name="Picture 16" descr="lsu.png"/>
+          <p:cNvPr id="16" name="Picture 15" descr="lsu.png"/>
           <p:cNvPicPr>
             <a:picLocks noChangeAspect="1"/>
           </p:cNvPicPr>
@@ -12683,8 +12113,8 @@
         </p:blipFill>
         <p:spPr>
           <a:xfrm>
-            <a:off x="1746504" y="2971800"/>
-            <a:ext cx="438912" cy="438912"/>
+            <a:off x="1647748" y="2653588"/>
+            <a:ext cx="380390" cy="380390"/>
           </a:xfrm>
           <a:prstGeom prst="rect">
             <a:avLst/>
@@ -12693,35 +12123,70 @@
       </p:pic>
       <p:sp>
         <p:nvSpPr>
+          <p:cNvPr id="17" name="TextBox 16"/>
+          <p:cNvSpPr txBox="1"/>
+          <p:nvPr/>
+        </p:nvSpPr>
+        <p:spPr>
+          <a:xfrm>
+            <a:off x="2286000" y="2688336"/>
+            <a:ext cx="4937760" cy="365760"/>
+          </a:xfrm>
+          <a:prstGeom prst="rect">
+            <a:avLst/>
+          </a:prstGeom>
+          <a:noFill/>
+        </p:spPr>
+        <p:txBody>
+          <a:bodyPr wrap="square" lIns="0" rIns="0" tIns="0" bIns="0">
+            <a:spAutoFit/>
+          </a:bodyPr>
+          <a:lstStyle/>
+          <a:p>
+            <a:pPr algn="l"/>
+            <a:r>
+              <a:rPr sz="1400" b="1" i="0">
+                <a:solidFill>
+                  <a:srgbClr val="FFFFFF"/>
+                </a:solidFill>
+                <a:latin typeface="Arial"/>
+              </a:rPr>
+              <a:t>Clemson at LSU</a:t>
+            </a:r>
+          </a:p>
+        </p:txBody>
+      </p:sp>
+      <p:sp>
+        <p:nvSpPr>
           <p:cNvPr id="18" name="TextBox 17"/>
           <p:cNvSpPr txBox="1"/>
           <p:nvPr/>
         </p:nvSpPr>
         <p:spPr>
           <a:xfrm>
-            <a:off x="2468880" y="2880360"/>
-            <a:ext cx="4937760" cy="365760"/>
-          </a:xfrm>
-          <a:prstGeom prst="rect">
-            <a:avLst/>
-          </a:prstGeom>
-          <a:noFill/>
-        </p:spPr>
-        <p:txBody>
-          <a:bodyPr wrap="square" lIns="0" rIns="0" tIns="0" bIns="0">
-            <a:spAutoFit/>
-          </a:bodyPr>
-          <a:lstStyle/>
-          <a:p>
-            <a:pPr algn="l"/>
-            <a:r>
-              <a:rPr sz="1450" b="1" i="0">
-                <a:solidFill>
-                  <a:srgbClr val="FFFFFF"/>
-                </a:solidFill>
-                <a:latin typeface="Arial"/>
-              </a:rPr>
-              <a:t>Clemson at LSU</a:t>
+            <a:off x="6400800" y="2596896"/>
+            <a:ext cx="4754880" cy="384048"/>
+          </a:xfrm>
+          <a:prstGeom prst="rect">
+            <a:avLst/>
+          </a:prstGeom>
+          <a:noFill/>
+        </p:spPr>
+        <p:txBody>
+          <a:bodyPr wrap="square" lIns="0" rIns="0" tIns="0" bIns="0">
+            <a:spAutoFit/>
+          </a:bodyPr>
+          <a:lstStyle/>
+          <a:p>
+            <a:pPr algn="r"/>
+            <a:r>
+              <a:rPr sz="1550" b="1" i="0">
+                <a:solidFill>
+                  <a:srgbClr val="F47321"/>
+                </a:solidFill>
+                <a:latin typeface="Arial"/>
+              </a:rPr>
+              <a:t>LSU 30 – Clemson 21</a:t>
             </a:r>
           </a:p>
         </p:txBody>
@@ -12734,43 +12199,8 @@
         </p:nvSpPr>
         <p:spPr>
           <a:xfrm>
-            <a:off x="2468880" y="3209544"/>
-            <a:ext cx="4937760" cy="347472"/>
-          </a:xfrm>
-          <a:prstGeom prst="rect">
-            <a:avLst/>
-          </a:prstGeom>
-          <a:noFill/>
-        </p:spPr>
-        <p:txBody>
-          <a:bodyPr wrap="square" lIns="0" rIns="0" tIns="0" bIns="0">
-            <a:spAutoFit/>
-          </a:bodyPr>
-          <a:lstStyle/>
-          <a:p>
-            <a:pPr algn="l"/>
-            <a:r>
-              <a:rPr sz="950" b="0" i="0">
-                <a:solidFill>
-                  <a:srgbClr val="CADCFC"/>
-                </a:solidFill>
-                <a:latin typeface="Arial"/>
-              </a:rPr>
-              <a:t>first-seen –10.5 (Aug 18) → now –10.5 · opened –11.5 · CLV +0</a:t>
-            </a:r>
-          </a:p>
-        </p:txBody>
-      </p:sp>
-      <p:sp>
-        <p:nvSpPr>
-          <p:cNvPr id="20" name="TextBox 19"/>
-          <p:cNvSpPr txBox="1"/>
-          <p:nvPr/>
-        </p:nvSpPr>
-        <p:spPr>
-          <a:xfrm>
-            <a:off x="7406640" y="2862072"/>
-            <a:ext cx="3749039" cy="384048"/>
+            <a:off x="6400800" y="2944368"/>
+            <a:ext cx="4754880" cy="228600"/>
           </a:xfrm>
           <a:prstGeom prst="rect">
             <a:avLst/>
@@ -12785,62 +12215,27 @@
           <a:p>
             <a:pPr algn="r"/>
             <a:r>
-              <a:rPr sz="1550" b="1" i="0">
-                <a:solidFill>
-                  <a:srgbClr val="F47321"/>
-                </a:solidFill>
-                <a:latin typeface="Arial"/>
-              </a:rPr>
-              <a:t>LSU 30 – Clemson 21</a:t>
-            </a:r>
-          </a:p>
-        </p:txBody>
-      </p:sp>
-      <p:sp>
-        <p:nvSpPr>
-          <p:cNvPr id="21" name="TextBox 20"/>
-          <p:cNvSpPr txBox="1"/>
-          <p:nvPr/>
-        </p:nvSpPr>
-        <p:spPr>
-          <a:xfrm>
-            <a:off x="7406640" y="3264408"/>
-            <a:ext cx="3749039" cy="274320"/>
-          </a:xfrm>
-          <a:prstGeom prst="rect">
-            <a:avLst/>
-          </a:prstGeom>
-          <a:noFill/>
-        </p:spPr>
-        <p:txBody>
-          <a:bodyPr wrap="square" lIns="0" rIns="0" tIns="0" bIns="0">
-            <a:spAutoFit/>
-          </a:bodyPr>
-          <a:lstStyle/>
-          <a:p>
-            <a:pPr algn="r"/>
-            <a:r>
               <a:rPr sz="850" b="0" i="0">
                 <a:solidFill>
                   <a:srgbClr val="8FA5C4"/>
                 </a:solidFill>
                 <a:latin typeface="Arial"/>
               </a:rPr>
-              <a:t>machine LSU –9 · market –10.5 / –10.5</a:t>
-            </a:r>
-          </a:p>
-        </p:txBody>
-      </p:sp>
-      <p:sp>
-        <p:nvSpPr>
-          <p:cNvPr id="22" name="Rounded Rectangle 21"/>
+              <a:t>market –10.5 / –10.5</a:t>
+            </a:r>
+          </a:p>
+        </p:txBody>
+      </p:sp>
+      <p:sp>
+        <p:nvSpPr>
+          <p:cNvPr id="20" name="Rounded Rectangle 19"/>
           <p:cNvSpPr/>
           <p:nvPr/>
         </p:nvSpPr>
         <p:spPr>
           <a:xfrm>
-            <a:off x="822960" y="3648456"/>
-            <a:ext cx="10515600" cy="768096"/>
+            <a:off x="822960" y="3246120"/>
+            <a:ext cx="10515600" cy="658368"/>
           </a:xfrm>
           <a:prstGeom prst="roundRect">
             <a:avLst/>
@@ -12877,14 +12272,14 @@
       </p:sp>
       <p:sp>
         <p:nvSpPr>
-          <p:cNvPr id="23" name="Oval 22"/>
+          <p:cNvPr id="21" name="Oval 20"/>
           <p:cNvSpPr/>
           <p:nvPr/>
         </p:nvSpPr>
         <p:spPr>
           <a:xfrm>
-            <a:off x="1005840" y="3758183"/>
-            <a:ext cx="548640" cy="548640"/>
+            <a:off x="1005840" y="3337560"/>
+            <a:ext cx="475488" cy="475488"/>
           </a:xfrm>
           <a:prstGeom prst="ellipse">
             <a:avLst/>
@@ -12921,7 +12316,7 @@
       </p:sp>
       <p:pic>
         <p:nvPicPr>
-          <p:cNvPr id="24" name="Picture 23" descr="louisville.png"/>
+          <p:cNvPr id="22" name="Picture 21" descr="louisville.png"/>
           <p:cNvPicPr>
             <a:picLocks noChangeAspect="1"/>
           </p:cNvPicPr>
@@ -12935,8 +12330,8 @@
         </p:blipFill>
         <p:spPr>
           <a:xfrm>
-            <a:off x="1060704" y="3813047"/>
-            <a:ext cx="438912" cy="438912"/>
+            <a:off x="1053388" y="3385108"/>
+            <a:ext cx="380390" cy="380390"/>
           </a:xfrm>
           <a:prstGeom prst="rect">
             <a:avLst/>
@@ -12945,14 +12340,14 @@
       </p:pic>
       <p:sp>
         <p:nvSpPr>
-          <p:cNvPr id="25" name="Oval 24"/>
+          <p:cNvPr id="23" name="Oval 22"/>
           <p:cNvSpPr/>
           <p:nvPr/>
         </p:nvSpPr>
         <p:spPr>
           <a:xfrm>
-            <a:off x="1691640" y="3758183"/>
-            <a:ext cx="548640" cy="548640"/>
+            <a:off x="1600200" y="3337560"/>
+            <a:ext cx="475488" cy="475488"/>
           </a:xfrm>
           <a:prstGeom prst="ellipse">
             <a:avLst/>
@@ -12989,7 +12384,7 @@
       </p:sp>
       <p:pic>
         <p:nvPicPr>
-          <p:cNvPr id="26" name="Picture 25" descr="olemiss.png"/>
+          <p:cNvPr id="24" name="Picture 23" descr="olemiss.png"/>
           <p:cNvPicPr>
             <a:picLocks noChangeAspect="1"/>
           </p:cNvPicPr>
@@ -13003,8 +12398,8 @@
         </p:blipFill>
         <p:spPr>
           <a:xfrm>
-            <a:off x="1746504" y="3813047"/>
-            <a:ext cx="438912" cy="438912"/>
+            <a:off x="1647748" y="3385108"/>
+            <a:ext cx="380390" cy="380390"/>
           </a:xfrm>
           <a:prstGeom prst="rect">
             <a:avLst/>
@@ -13013,84 +12408,84 @@
       </p:pic>
       <p:sp>
         <p:nvSpPr>
+          <p:cNvPr id="25" name="TextBox 24"/>
+          <p:cNvSpPr txBox="1"/>
+          <p:nvPr/>
+        </p:nvSpPr>
+        <p:spPr>
+          <a:xfrm>
+            <a:off x="2286000" y="3419856"/>
+            <a:ext cx="4937760" cy="365760"/>
+          </a:xfrm>
+          <a:prstGeom prst="rect">
+            <a:avLst/>
+          </a:prstGeom>
+          <a:noFill/>
+        </p:spPr>
+        <p:txBody>
+          <a:bodyPr wrap="square" lIns="0" rIns="0" tIns="0" bIns="0">
+            <a:spAutoFit/>
+          </a:bodyPr>
+          <a:lstStyle/>
+          <a:p>
+            <a:pPr algn="l"/>
+            <a:r>
+              <a:rPr sz="1400" b="1" i="0">
+                <a:solidFill>
+                  <a:srgbClr val="FFFFFF"/>
+                </a:solidFill>
+                <a:latin typeface="Arial"/>
+              </a:rPr>
+              <a:t>Louisville vs Ole Miss</a:t>
+            </a:r>
+          </a:p>
+        </p:txBody>
+      </p:sp>
+      <p:sp>
+        <p:nvSpPr>
+          <p:cNvPr id="26" name="TextBox 25"/>
+          <p:cNvSpPr txBox="1"/>
+          <p:nvPr/>
+        </p:nvSpPr>
+        <p:spPr>
+          <a:xfrm>
+            <a:off x="6400800" y="3328415"/>
+            <a:ext cx="4754880" cy="384048"/>
+          </a:xfrm>
+          <a:prstGeom prst="rect">
+            <a:avLst/>
+          </a:prstGeom>
+          <a:noFill/>
+        </p:spPr>
+        <p:txBody>
+          <a:bodyPr wrap="square" lIns="0" rIns="0" tIns="0" bIns="0">
+            <a:spAutoFit/>
+          </a:bodyPr>
+          <a:lstStyle/>
+          <a:p>
+            <a:pPr algn="r"/>
+            <a:r>
+              <a:rPr sz="1550" b="1" i="0">
+                <a:solidFill>
+                  <a:srgbClr val="F47321"/>
+                </a:solidFill>
+                <a:latin typeface="Arial"/>
+              </a:rPr>
+              <a:t>Ole Miss 31 – Louisville 25</a:t>
+            </a:r>
+          </a:p>
+        </p:txBody>
+      </p:sp>
+      <p:sp>
+        <p:nvSpPr>
           <p:cNvPr id="27" name="TextBox 26"/>
           <p:cNvSpPr txBox="1"/>
           <p:nvPr/>
         </p:nvSpPr>
         <p:spPr>
           <a:xfrm>
-            <a:off x="2468880" y="3721607"/>
-            <a:ext cx="4937760" cy="365760"/>
-          </a:xfrm>
-          <a:prstGeom prst="rect">
-            <a:avLst/>
-          </a:prstGeom>
-          <a:noFill/>
-        </p:spPr>
-        <p:txBody>
-          <a:bodyPr wrap="square" lIns="0" rIns="0" tIns="0" bIns="0">
-            <a:spAutoFit/>
-          </a:bodyPr>
-          <a:lstStyle/>
-          <a:p>
-            <a:pPr algn="l"/>
-            <a:r>
-              <a:rPr sz="1450" b="1" i="0">
-                <a:solidFill>
-                  <a:srgbClr val="FFFFFF"/>
-                </a:solidFill>
-                <a:latin typeface="Arial"/>
-              </a:rPr>
-              <a:t>Louisville vs Ole Miss</a:t>
-            </a:r>
-          </a:p>
-        </p:txBody>
-      </p:sp>
-      <p:sp>
-        <p:nvSpPr>
-          <p:cNvPr id="28" name="TextBox 27"/>
-          <p:cNvSpPr txBox="1"/>
-          <p:nvPr/>
-        </p:nvSpPr>
-        <p:spPr>
-          <a:xfrm>
-            <a:off x="2468880" y="4050791"/>
-            <a:ext cx="4937760" cy="347472"/>
-          </a:xfrm>
-          <a:prstGeom prst="rect">
-            <a:avLst/>
-          </a:prstGeom>
-          <a:noFill/>
-        </p:spPr>
-        <p:txBody>
-          <a:bodyPr wrap="square" lIns="0" rIns="0" tIns="0" bIns="0">
-            <a:spAutoFit/>
-          </a:bodyPr>
-          <a:lstStyle/>
-          <a:p>
-            <a:pPr algn="l"/>
-            <a:r>
-              <a:rPr sz="950" b="0" i="0">
-                <a:solidFill>
-                  <a:srgbClr val="CADCFC"/>
-                </a:solidFill>
-                <a:latin typeface="Arial"/>
-              </a:rPr>
-              <a:t>first-seen –6.5 (Aug 18) → now –7 · opened –8.5 · CLV -0.5</a:t>
-            </a:r>
-          </a:p>
-        </p:txBody>
-      </p:sp>
-      <p:sp>
-        <p:nvSpPr>
-          <p:cNvPr id="29" name="TextBox 28"/>
-          <p:cNvSpPr txBox="1"/>
-          <p:nvPr/>
-        </p:nvSpPr>
-        <p:spPr>
-          <a:xfrm>
-            <a:off x="7406640" y="3703320"/>
-            <a:ext cx="3749039" cy="384048"/>
+            <a:off x="6400800" y="3675887"/>
+            <a:ext cx="4754880" cy="228600"/>
           </a:xfrm>
           <a:prstGeom prst="rect">
             <a:avLst/>
@@ -13105,62 +12500,27 @@
           <a:p>
             <a:pPr algn="r"/>
             <a:r>
-              <a:rPr sz="1550" b="1" i="0">
-                <a:solidFill>
-                  <a:srgbClr val="F47321"/>
-                </a:solidFill>
-                <a:latin typeface="Arial"/>
-              </a:rPr>
-              <a:t>Ole Miss 31 – Louisville 25</a:t>
-            </a:r>
-          </a:p>
-        </p:txBody>
-      </p:sp>
-      <p:sp>
-        <p:nvSpPr>
-          <p:cNvPr id="30" name="TextBox 29"/>
-          <p:cNvSpPr txBox="1"/>
-          <p:nvPr/>
-        </p:nvSpPr>
-        <p:spPr>
-          <a:xfrm>
-            <a:off x="7406640" y="4105656"/>
-            <a:ext cx="3749039" cy="274320"/>
-          </a:xfrm>
-          <a:prstGeom prst="rect">
-            <a:avLst/>
-          </a:prstGeom>
-          <a:noFill/>
-        </p:spPr>
-        <p:txBody>
-          <a:bodyPr wrap="square" lIns="0" rIns="0" tIns="0" bIns="0">
-            <a:spAutoFit/>
-          </a:bodyPr>
-          <a:lstStyle/>
-          <a:p>
-            <a:pPr algn="r"/>
-            <a:r>
               <a:rPr sz="850" b="0" i="0">
                 <a:solidFill>
                   <a:srgbClr val="8FA5C4"/>
                 </a:solidFill>
                 <a:latin typeface="Arial"/>
               </a:rPr>
-              <a:t>machine Ole Miss –6.5 · market –7 / –6.5</a:t>
-            </a:r>
-          </a:p>
-        </p:txBody>
-      </p:sp>
-      <p:sp>
-        <p:nvSpPr>
-          <p:cNvPr id="31" name="Rounded Rectangle 30"/>
+              <a:t>market –7 / –6.5</a:t>
+            </a:r>
+          </a:p>
+        </p:txBody>
+      </p:sp>
+      <p:sp>
+        <p:nvSpPr>
+          <p:cNvPr id="28" name="Rounded Rectangle 27"/>
           <p:cNvSpPr/>
           <p:nvPr/>
         </p:nvSpPr>
         <p:spPr>
           <a:xfrm>
-            <a:off x="822960" y="4489704"/>
-            <a:ext cx="10515600" cy="768096"/>
+            <a:off x="822960" y="3977639"/>
+            <a:ext cx="10515600" cy="658368"/>
           </a:xfrm>
           <a:prstGeom prst="roundRect">
             <a:avLst/>
@@ -13197,14 +12557,14 @@
       </p:sp>
       <p:sp>
         <p:nvSpPr>
-          <p:cNvPr id="32" name="Oval 31"/>
+          <p:cNvPr id="29" name="Oval 28"/>
           <p:cNvSpPr/>
           <p:nvPr/>
         </p:nvSpPr>
         <p:spPr>
           <a:xfrm>
-            <a:off x="1005840" y="4599432"/>
-            <a:ext cx="548640" cy="548640"/>
+            <a:off x="1005840" y="4069079"/>
+            <a:ext cx="475488" cy="475488"/>
           </a:xfrm>
           <a:prstGeom prst="ellipse">
             <a:avLst/>
@@ -13241,7 +12601,7 @@
       </p:sp>
       <p:pic>
         <p:nvPicPr>
-          <p:cNvPr id="33" name="Picture 32" descr="wisconsin.png"/>
+          <p:cNvPr id="30" name="Picture 29" descr="wisconsin.png"/>
           <p:cNvPicPr>
             <a:picLocks noChangeAspect="1"/>
           </p:cNvPicPr>
@@ -13255,8 +12615,8 @@
         </p:blipFill>
         <p:spPr>
           <a:xfrm>
-            <a:off x="1060704" y="4654296"/>
-            <a:ext cx="438912" cy="438912"/>
+            <a:off x="1053388" y="4116628"/>
+            <a:ext cx="380390" cy="380390"/>
           </a:xfrm>
           <a:prstGeom prst="rect">
             <a:avLst/>
@@ -13265,14 +12625,14 @@
       </p:pic>
       <p:sp>
         <p:nvSpPr>
-          <p:cNvPr id="34" name="Oval 33"/>
+          <p:cNvPr id="31" name="Oval 30"/>
           <p:cNvSpPr/>
           <p:nvPr/>
         </p:nvSpPr>
         <p:spPr>
           <a:xfrm>
-            <a:off x="1691640" y="4599432"/>
-            <a:ext cx="548640" cy="548640"/>
+            <a:off x="1600200" y="4069079"/>
+            <a:ext cx="475488" cy="475488"/>
           </a:xfrm>
           <a:prstGeom prst="ellipse">
             <a:avLst/>
@@ -13309,7 +12669,7 @@
       </p:sp>
       <p:pic>
         <p:nvPicPr>
-          <p:cNvPr id="35" name="Picture 34" descr="notredame.png"/>
+          <p:cNvPr id="32" name="Picture 31" descr="notredame.png"/>
           <p:cNvPicPr>
             <a:picLocks noChangeAspect="1"/>
           </p:cNvPicPr>
@@ -13323,8 +12683,8 @@
         </p:blipFill>
         <p:spPr>
           <a:xfrm>
-            <a:off x="1746504" y="4654296"/>
-            <a:ext cx="438912" cy="438912"/>
+            <a:off x="1647748" y="4116628"/>
+            <a:ext cx="380390" cy="380390"/>
           </a:xfrm>
           <a:prstGeom prst="rect">
             <a:avLst/>
@@ -13333,13 +12693,13 @@
       </p:pic>
       <p:sp>
         <p:nvSpPr>
-          <p:cNvPr id="36" name="TextBox 35"/>
-          <p:cNvSpPr txBox="1"/>
-          <p:nvPr/>
-        </p:nvSpPr>
-        <p:spPr>
-          <a:xfrm>
-            <a:off x="2468880" y="4562856"/>
+          <p:cNvPr id="33" name="TextBox 32"/>
+          <p:cNvSpPr txBox="1"/>
+          <p:nvPr/>
+        </p:nvSpPr>
+        <p:spPr>
+          <a:xfrm>
+            <a:off x="2286000" y="4151376"/>
             <a:ext cx="4937760" cy="365760"/>
           </a:xfrm>
           <a:prstGeom prst="rect">
@@ -13355,7 +12715,7 @@
           <a:p>
             <a:pPr algn="l"/>
             <a:r>
-              <a:rPr sz="1450" b="1" i="0">
+              <a:rPr sz="1400" b="1" i="0">
                 <a:solidFill>
                   <a:srgbClr val="FFFFFF"/>
                 </a:solidFill>
@@ -13368,49 +12728,14 @@
       </p:sp>
       <p:sp>
         <p:nvSpPr>
-          <p:cNvPr id="37" name="TextBox 36"/>
-          <p:cNvSpPr txBox="1"/>
-          <p:nvPr/>
-        </p:nvSpPr>
-        <p:spPr>
-          <a:xfrm>
-            <a:off x="2468880" y="4892040"/>
-            <a:ext cx="4937760" cy="347472"/>
-          </a:xfrm>
-          <a:prstGeom prst="rect">
-            <a:avLst/>
-          </a:prstGeom>
-          <a:noFill/>
-        </p:spPr>
-        <p:txBody>
-          <a:bodyPr wrap="square" lIns="0" rIns="0" tIns="0" bIns="0">
-            <a:spAutoFit/>
-          </a:bodyPr>
-          <a:lstStyle/>
-          <a:p>
-            <a:pPr algn="l"/>
-            <a:r>
-              <a:rPr sz="950" b="0" i="0">
-                <a:solidFill>
-                  <a:srgbClr val="CADCFC"/>
-                </a:solidFill>
-                <a:latin typeface="Arial"/>
-              </a:rPr>
-              <a:t>opened –16.5 → now –20.5 (first-seen excluded: sides-flip data error)</a:t>
-            </a:r>
-          </a:p>
-        </p:txBody>
-      </p:sp>
-      <p:sp>
-        <p:nvSpPr>
-          <p:cNvPr id="38" name="TextBox 37"/>
-          <p:cNvSpPr txBox="1"/>
-          <p:nvPr/>
-        </p:nvSpPr>
-        <p:spPr>
-          <a:xfrm>
-            <a:off x="7406640" y="4544568"/>
-            <a:ext cx="3749039" cy="384048"/>
+          <p:cNvPr id="34" name="TextBox 33"/>
+          <p:cNvSpPr txBox="1"/>
+          <p:nvPr/>
+        </p:nvSpPr>
+        <p:spPr>
+          <a:xfrm>
+            <a:off x="6400800" y="4059935"/>
+            <a:ext cx="4754880" cy="384048"/>
           </a:xfrm>
           <a:prstGeom prst="rect">
             <a:avLst/>
@@ -13438,14 +12763,14 @@
       </p:sp>
       <p:sp>
         <p:nvSpPr>
-          <p:cNvPr id="39" name="TextBox 38"/>
-          <p:cNvSpPr txBox="1"/>
-          <p:nvPr/>
-        </p:nvSpPr>
-        <p:spPr>
-          <a:xfrm>
-            <a:off x="7406640" y="4946904"/>
-            <a:ext cx="3749039" cy="274320"/>
+          <p:cNvPr id="35" name="TextBox 34"/>
+          <p:cNvSpPr txBox="1"/>
+          <p:nvPr/>
+        </p:nvSpPr>
+        <p:spPr>
+          <a:xfrm>
+            <a:off x="6400800" y="4407407"/>
+            <a:ext cx="4754880" cy="228600"/>
           </a:xfrm>
           <a:prstGeom prst="rect">
             <a:avLst/>
@@ -13466,21 +12791,21 @@
                 </a:solidFill>
                 <a:latin typeface="Arial"/>
               </a:rPr>
-              <a:t>machine ND –21 · market –20.5 / –20</a:t>
-            </a:r>
-          </a:p>
-        </p:txBody>
-      </p:sp>
-      <p:sp>
-        <p:nvSpPr>
-          <p:cNvPr id="40" name="Rounded Rectangle 39"/>
+              <a:t>market –20.5 / –20</a:t>
+            </a:r>
+          </a:p>
+        </p:txBody>
+      </p:sp>
+      <p:sp>
+        <p:nvSpPr>
+          <p:cNvPr id="36" name="Rounded Rectangle 35"/>
           <p:cNvSpPr/>
           <p:nvPr/>
         </p:nvSpPr>
         <p:spPr>
           <a:xfrm>
-            <a:off x="822960" y="5330952"/>
-            <a:ext cx="10515600" cy="768096"/>
+            <a:off x="822960" y="4709159"/>
+            <a:ext cx="10515600" cy="658368"/>
           </a:xfrm>
           <a:prstGeom prst="roundRect">
             <a:avLst/>
@@ -13517,14 +12842,14 @@
       </p:sp>
       <p:sp>
         <p:nvSpPr>
-          <p:cNvPr id="41" name="Oval 40"/>
+          <p:cNvPr id="37" name="Oval 36"/>
           <p:cNvSpPr/>
           <p:nvPr/>
         </p:nvSpPr>
         <p:spPr>
           <a:xfrm>
-            <a:off x="1005840" y="5440680"/>
-            <a:ext cx="548640" cy="548640"/>
+            <a:off x="1005840" y="4800599"/>
+            <a:ext cx="475488" cy="475488"/>
           </a:xfrm>
           <a:prstGeom prst="ellipse">
             <a:avLst/>
@@ -13561,7 +12886,7 @@
       </p:sp>
       <p:pic>
         <p:nvPicPr>
-          <p:cNvPr id="42" name="Picture 41" descr="smu.png"/>
+          <p:cNvPr id="38" name="Picture 37" descr="smu.png"/>
           <p:cNvPicPr>
             <a:picLocks noChangeAspect="1"/>
           </p:cNvPicPr>
@@ -13575,8 +12900,8 @@
         </p:blipFill>
         <p:spPr>
           <a:xfrm>
-            <a:off x="1060704" y="5495544"/>
-            <a:ext cx="438912" cy="438912"/>
+            <a:off x="1053388" y="4848148"/>
+            <a:ext cx="380390" cy="380390"/>
           </a:xfrm>
           <a:prstGeom prst="rect">
             <a:avLst/>
@@ -13585,14 +12910,14 @@
       </p:pic>
       <p:sp>
         <p:nvSpPr>
-          <p:cNvPr id="43" name="Oval 42"/>
+          <p:cNvPr id="39" name="Oval 38"/>
           <p:cNvSpPr/>
           <p:nvPr/>
         </p:nvSpPr>
         <p:spPr>
           <a:xfrm>
-            <a:off x="1691640" y="5440680"/>
-            <a:ext cx="548640" cy="548640"/>
+            <a:off x="1600200" y="4800599"/>
+            <a:ext cx="475488" cy="475488"/>
           </a:xfrm>
           <a:prstGeom prst="ellipse">
             <a:avLst/>
@@ -13629,7 +12954,7 @@
       </p:sp>
       <p:pic>
         <p:nvPicPr>
-          <p:cNvPr id="44" name="Picture 43" descr="fsu.png"/>
+          <p:cNvPr id="40" name="Picture 39" descr="fsu.png"/>
           <p:cNvPicPr>
             <a:picLocks noChangeAspect="1"/>
           </p:cNvPicPr>
@@ -13643,8 +12968,8 @@
         </p:blipFill>
         <p:spPr>
           <a:xfrm>
-            <a:off x="1746504" y="5495544"/>
-            <a:ext cx="438912" cy="438912"/>
+            <a:off x="1647748" y="4848148"/>
+            <a:ext cx="380390" cy="380390"/>
           </a:xfrm>
           <a:prstGeom prst="rect">
             <a:avLst/>
@@ -13653,70 +12978,219 @@
       </p:pic>
       <p:sp>
         <p:nvSpPr>
+          <p:cNvPr id="41" name="TextBox 40"/>
+          <p:cNvSpPr txBox="1"/>
+          <p:nvPr/>
+        </p:nvSpPr>
+        <p:spPr>
+          <a:xfrm>
+            <a:off x="2286000" y="4882896"/>
+            <a:ext cx="4937760" cy="365760"/>
+          </a:xfrm>
+          <a:prstGeom prst="rect">
+            <a:avLst/>
+          </a:prstGeom>
+          <a:noFill/>
+        </p:spPr>
+        <p:txBody>
+          <a:bodyPr wrap="square" lIns="0" rIns="0" tIns="0" bIns="0">
+            <a:spAutoFit/>
+          </a:bodyPr>
+          <a:lstStyle/>
+          <a:p>
+            <a:pPr algn="l"/>
+            <a:r>
+              <a:rPr sz="1400" b="1" i="0">
+                <a:solidFill>
+                  <a:srgbClr val="FFFFFF"/>
+                </a:solidFill>
+                <a:latin typeface="Arial"/>
+              </a:rPr>
+              <a:t>SMU at Florida State</a:t>
+            </a:r>
+          </a:p>
+        </p:txBody>
+      </p:sp>
+      <p:sp>
+        <p:nvSpPr>
+          <p:cNvPr id="42" name="TextBox 41"/>
+          <p:cNvSpPr txBox="1"/>
+          <p:nvPr/>
+        </p:nvSpPr>
+        <p:spPr>
+          <a:xfrm>
+            <a:off x="6400800" y="4791455"/>
+            <a:ext cx="4754880" cy="384048"/>
+          </a:xfrm>
+          <a:prstGeom prst="rect">
+            <a:avLst/>
+          </a:prstGeom>
+          <a:noFill/>
+        </p:spPr>
+        <p:txBody>
+          <a:bodyPr wrap="square" lIns="0" rIns="0" tIns="0" bIns="0">
+            <a:spAutoFit/>
+          </a:bodyPr>
+          <a:lstStyle/>
+          <a:p>
+            <a:pPr algn="r"/>
+            <a:r>
+              <a:rPr sz="1550" b="1" i="0">
+                <a:solidFill>
+                  <a:srgbClr val="F47321"/>
+                </a:solidFill>
+                <a:latin typeface="Arial"/>
+              </a:rPr>
+              <a:t>FSU 27 – SMU 26</a:t>
+            </a:r>
+          </a:p>
+        </p:txBody>
+      </p:sp>
+      <p:sp>
+        <p:nvSpPr>
+          <p:cNvPr id="43" name="TextBox 42"/>
+          <p:cNvSpPr txBox="1"/>
+          <p:nvPr/>
+        </p:nvSpPr>
+        <p:spPr>
+          <a:xfrm>
+            <a:off x="6400800" y="5138927"/>
+            <a:ext cx="4754880" cy="228600"/>
+          </a:xfrm>
+          <a:prstGeom prst="rect">
+            <a:avLst/>
+          </a:prstGeom>
+          <a:noFill/>
+        </p:spPr>
+        <p:txBody>
+          <a:bodyPr wrap="square" lIns="0" rIns="0" tIns="0" bIns="0">
+            <a:spAutoFit/>
+          </a:bodyPr>
+          <a:lstStyle/>
+          <a:p>
+            <a:pPr algn="r"/>
+            <a:r>
+              <a:rPr sz="850" b="0" i="0">
+                <a:solidFill>
+                  <a:srgbClr val="8FA5C4"/>
+                </a:solidFill>
+                <a:latin typeface="Arial"/>
+              </a:rPr>
+              <a:t>market +3 / +3</a:t>
+            </a:r>
+          </a:p>
+        </p:txBody>
+      </p:sp>
+      <p:sp>
+        <p:nvSpPr>
+          <p:cNvPr id="44" name="Rounded Rectangle 43"/>
+          <p:cNvSpPr/>
+          <p:nvPr/>
+        </p:nvSpPr>
+        <p:spPr>
+          <a:xfrm>
+            <a:off x="822960" y="5513831"/>
+            <a:ext cx="10515600" cy="932688"/>
+          </a:xfrm>
+          <a:prstGeom prst="roundRect">
+            <a:avLst/>
+          </a:prstGeom>
+          <a:solidFill>
+            <a:srgbClr val="F47321"/>
+          </a:solidFill>
+          <a:ln>
+            <a:noFill/>
+          </a:ln>
+          <a:effectLst/>
+        </p:spPr>
+        <p:style>
+          <a:lnRef idx="1">
+            <a:schemeClr val="accent1"/>
+          </a:lnRef>
+          <a:fillRef idx="3">
+            <a:schemeClr val="accent1"/>
+          </a:fillRef>
+          <a:effectRef idx="2">
+            <a:schemeClr val="accent1"/>
+          </a:effectRef>
+          <a:fontRef idx="minor">
+            <a:schemeClr val="lt1"/>
+          </a:fontRef>
+        </p:style>
+        <p:txBody>
+          <a:bodyPr rtlCol="0" anchor="ctr"/>
+          <a:lstStyle/>
+          <a:p>
+            <a:pPr algn="ctr"/>
+          </a:p>
+        </p:txBody>
+      </p:sp>
+      <p:sp>
+        <p:nvSpPr>
           <p:cNvPr id="45" name="TextBox 44"/>
           <p:cNvSpPr txBox="1"/>
           <p:nvPr/>
         </p:nvSpPr>
         <p:spPr>
           <a:xfrm>
-            <a:off x="2468880" y="5404104"/>
-            <a:ext cx="4937760" cy="365760"/>
-          </a:xfrm>
-          <a:prstGeom prst="rect">
-            <a:avLst/>
-          </a:prstGeom>
-          <a:noFill/>
-        </p:spPr>
-        <p:txBody>
-          <a:bodyPr wrap="square" lIns="0" rIns="0" tIns="0" bIns="0">
-            <a:spAutoFit/>
-          </a:bodyPr>
-          <a:lstStyle/>
-          <a:p>
-            <a:pPr algn="l"/>
-            <a:r>
-              <a:rPr sz="1450" b="1" i="0">
+            <a:off x="1097280" y="5596127"/>
+            <a:ext cx="2743200" cy="320040"/>
+          </a:xfrm>
+          <a:prstGeom prst="rect">
+            <a:avLst/>
+          </a:prstGeom>
+          <a:noFill/>
+        </p:spPr>
+        <p:txBody>
+          <a:bodyPr wrap="square" lIns="0" rIns="0" tIns="0" bIns="0">
+            <a:spAutoFit/>
+          </a:bodyPr>
+          <a:lstStyle/>
+          <a:p>
+            <a:pPr algn="l"/>
+            <a:r>
+              <a:rPr sz="1300" b="1" i="0">
+                <a:solidFill>
+                  <a:srgbClr val="0A2851"/>
+                </a:solidFill>
+                <a:latin typeface="Arial"/>
+              </a:rPr>
+              <a:t>★ SUPERDOG</a:t>
+            </a:r>
+          </a:p>
+        </p:txBody>
+      </p:sp>
+      <p:sp>
+        <p:nvSpPr>
+          <p:cNvPr id="46" name="TextBox 45"/>
+          <p:cNvSpPr txBox="1"/>
+          <p:nvPr/>
+        </p:nvSpPr>
+        <p:spPr>
+          <a:xfrm>
+            <a:off x="3291840" y="5596127"/>
+            <a:ext cx="7863840" cy="320040"/>
+          </a:xfrm>
+          <a:prstGeom prst="rect">
+            <a:avLst/>
+          </a:prstGeom>
+          <a:noFill/>
+        </p:spPr>
+        <p:txBody>
+          <a:bodyPr wrap="square" lIns="0" rIns="0" tIns="0" bIns="0">
+            <a:spAutoFit/>
+          </a:bodyPr>
+          <a:lstStyle/>
+          <a:p>
+            <a:pPr algn="l"/>
+            <a:r>
+              <a:rPr sz="1350" b="1" i="0">
                 <a:solidFill>
                   <a:srgbClr val="FFFFFF"/>
                 </a:solidFill>
                 <a:latin typeface="Arial"/>
               </a:rPr>
-              <a:t>SMU at Florida State</a:t>
-            </a:r>
-          </a:p>
-        </p:txBody>
-      </p:sp>
-      <p:sp>
-        <p:nvSpPr>
-          <p:cNvPr id="46" name="TextBox 45"/>
-          <p:cNvSpPr txBox="1"/>
-          <p:nvPr/>
-        </p:nvSpPr>
-        <p:spPr>
-          <a:xfrm>
-            <a:off x="2468880" y="5733288"/>
-            <a:ext cx="4937760" cy="347472"/>
-          </a:xfrm>
-          <a:prstGeom prst="rect">
-            <a:avLst/>
-          </a:prstGeom>
-          <a:noFill/>
-        </p:spPr>
-        <p:txBody>
-          <a:bodyPr wrap="square" lIns="0" rIns="0" tIns="0" bIns="0">
-            <a:spAutoFit/>
-          </a:bodyPr>
-          <a:lstStyle/>
-          <a:p>
-            <a:pPr algn="l"/>
-            <a:r>
-              <a:rPr sz="950" b="0" i="0">
-                <a:solidFill>
-                  <a:srgbClr val="CADCFC"/>
-                </a:solidFill>
-                <a:latin typeface="Arial"/>
-              </a:rPr>
-              <a:t>first-seen +2.5 (Aug 18) → now +3 · CLV -0.5</a:t>
+              <a:t>Coastal Carolina +21.5 at West Virginia · ML +1000</a:t>
             </a:r>
           </a:p>
         </p:txBody>
@@ -13729,29 +13203,29 @@
         </p:nvSpPr>
         <p:spPr>
           <a:xfrm>
-            <a:off x="7406640" y="5385816"/>
-            <a:ext cx="3749039" cy="384048"/>
-          </a:xfrm>
-          <a:prstGeom prst="rect">
-            <a:avLst/>
-          </a:prstGeom>
-          <a:noFill/>
-        </p:spPr>
-        <p:txBody>
-          <a:bodyPr wrap="square" lIns="0" rIns="0" tIns="0" bIns="0">
-            <a:spAutoFit/>
-          </a:bodyPr>
-          <a:lstStyle/>
-          <a:p>
-            <a:pPr algn="r"/>
-            <a:r>
-              <a:rPr sz="1550" b="1" i="0">
-                <a:solidFill>
-                  <a:srgbClr val="F47321"/>
-                </a:solidFill>
-                <a:latin typeface="Arial"/>
-              </a:rPr>
-              <a:t>FSU 27 – SMU 26</a:t>
+            <a:off x="1097280" y="5998464"/>
+            <a:ext cx="2743200" cy="320040"/>
+          </a:xfrm>
+          <a:prstGeom prst="rect">
+            <a:avLst/>
+          </a:prstGeom>
+          <a:noFill/>
+        </p:spPr>
+        <p:txBody>
+          <a:bodyPr wrap="square" lIns="0" rIns="0" tIns="0" bIns="0">
+            <a:spAutoFit/>
+          </a:bodyPr>
+          <a:lstStyle/>
+          <a:p>
+            <a:pPr algn="l"/>
+            <a:r>
+              <a:rPr sz="1300" b="1" i="0">
+                <a:solidFill>
+                  <a:srgbClr val="0A2851"/>
+                </a:solidFill>
+                <a:latin typeface="Arial"/>
+              </a:rPr>
+              <a:t>★ GIANT KILLER</a:t>
             </a:r>
           </a:p>
         </p:txBody>
@@ -13764,64 +13238,64 @@
         </p:nvSpPr>
         <p:spPr>
           <a:xfrm>
-            <a:off x="7406640" y="5788152"/>
-            <a:ext cx="3749039" cy="274320"/>
-          </a:xfrm>
-          <a:prstGeom prst="rect">
-            <a:avLst/>
-          </a:prstGeom>
-          <a:noFill/>
-        </p:spPr>
-        <p:txBody>
-          <a:bodyPr wrap="square" lIns="0" rIns="0" tIns="0" bIns="0">
-            <a:spAutoFit/>
-          </a:bodyPr>
-          <a:lstStyle/>
-          <a:p>
-            <a:pPr algn="r"/>
-            <a:r>
-              <a:rPr sz="850" b="0" i="0">
+            <a:off x="3291840" y="5998464"/>
+            <a:ext cx="7863840" cy="320040"/>
+          </a:xfrm>
+          <a:prstGeom prst="rect">
+            <a:avLst/>
+          </a:prstGeom>
+          <a:noFill/>
+        </p:spPr>
+        <p:txBody>
+          <a:bodyPr wrap="square" lIns="0" rIns="0" tIns="0" bIns="0">
+            <a:spAutoFit/>
+          </a:bodyPr>
+          <a:lstStyle/>
+          <a:p>
+            <a:pPr algn="l"/>
+            <a:r>
+              <a:rPr sz="1350" b="1" i="0">
+                <a:solidFill>
+                  <a:srgbClr val="FFFFFF"/>
+                </a:solidFill>
+                <a:latin typeface="Arial"/>
+              </a:rPr>
+              <a:t>Washington State +23.5 at #17 Washington · ML +1300</a:t>
+            </a:r>
+          </a:p>
+        </p:txBody>
+      </p:sp>
+      <p:sp>
+        <p:nvSpPr>
+          <p:cNvPr id="49" name="TextBox 48"/>
+          <p:cNvSpPr txBox="1"/>
+          <p:nvPr/>
+        </p:nvSpPr>
+        <p:spPr>
+          <a:xfrm>
+            <a:off x="822960" y="6565392"/>
+            <a:ext cx="10515600" cy="274320"/>
+          </a:xfrm>
+          <a:prstGeom prst="rect">
+            <a:avLst/>
+          </a:prstGeom>
+          <a:noFill/>
+        </p:spPr>
+        <p:txBody>
+          <a:bodyPr wrap="square" lIns="0" rIns="0" tIns="0" bIns="0">
+            <a:spAutoFit/>
+          </a:bodyPr>
+          <a:lstStyle/>
+          <a:p>
+            <a:pPr algn="l"/>
+            <a:r>
+              <a:rPr sz="900" b="0" i="1">
                 <a:solidFill>
                   <a:srgbClr val="8FA5C4"/>
                 </a:solidFill>
                 <a:latin typeface="Arial"/>
               </a:rPr>
-              <a:t>machine FSU –0.5 · market +3 / +3</a:t>
-            </a:r>
-          </a:p>
-        </p:txBody>
-      </p:sp>
-      <p:sp>
-        <p:nvSpPr>
-          <p:cNvPr id="49" name="TextBox 48"/>
-          <p:cNvSpPr txBox="1"/>
-          <p:nvPr/>
-        </p:nvSpPr>
-        <p:spPr>
-          <a:xfrm>
-            <a:off x="822960" y="6263640"/>
-            <a:ext cx="10515600" cy="457200"/>
-          </a:xfrm>
-          <a:prstGeom prst="rect">
-            <a:avLst/>
-          </a:prstGeom>
-          <a:noFill/>
-        </p:spPr>
-        <p:txBody>
-          <a:bodyPr wrap="square" lIns="0" rIns="0" tIns="0" bIns="0">
-            <a:spAutoFit/>
-          </a:bodyPr>
-          <a:lstStyle/>
-          <a:p>
-            <a:pPr algn="l"/>
-            <a:r>
-              <a:rPr sz="1100" b="0" i="1">
-                <a:solidFill>
-                  <a:srgbClr val="8FA5C4"/>
-                </a:solidFill>
-                <a:latin typeface="Arial"/>
-              </a:rPr>
-              <a:t>Paper record after Week 0: stated leans 1–2 — graded vs first-seen lines, never moved ones. Research, not picks.</a:t>
+              <a:t>projected scores = machine margin on the market total · superdogs = dog to win outright, points = the spread · graded vs first-seen lines · research, not picks</a:t>
             </a:r>
           </a:p>
         </p:txBody>

</xml_diff>

<commit_message>
Score bug: score prediction replaces 'the gap' (Lucas's in-Slides edit, generator-ized)
Co-Authored-By: Claude Fable 5 <noreply@anthropic.com>
</commit_message>
<xml_diff>
--- a/decks/2026_Week1_Episode2.pptx
+++ b/decks/2026_Week1_Episode2.pptx
@@ -7155,13 +7155,13 @@
           <a:p>
             <a:pPr algn="l"/>
             <a:r>
-              <a:rPr sz="1200" b="1" i="0">
+              <a:rPr sz="1500" b="1" i="0">
                 <a:solidFill>
                   <a:srgbClr val="F47321"/>
                 </a:solidFill>
                 <a:latin typeface="Arial"/>
               </a:rPr>
-              <a:t>no gap — watch, don't touch</a:t>
+              <a:t>ND 34 – Wisconsin 13</a:t>
             </a:r>
           </a:p>
         </p:txBody>
@@ -7196,7 +7196,7 @@
                 </a:solidFill>
                 <a:latin typeface="Arial"/>
               </a:rPr>
-              <a:t>the gap</a:t>
+              <a:t>score prediction</a:t>
             </a:r>
           </a:p>
         </p:txBody>
@@ -9801,13 +9801,13 @@
           <a:p>
             <a:pPr algn="l"/>
             <a:r>
-              <a:rPr sz="1200" b="1" i="0">
+              <a:rPr sz="1500" b="1" i="0">
                 <a:solidFill>
                   <a:srgbClr val="F47321"/>
                 </a:solidFill>
                 <a:latin typeface="Arial"/>
               </a:rPr>
-              <a:t>RED: home dog outright</a:t>
+              <a:t>FSU 27 – SMU 26</a:t>
             </a:r>
           </a:p>
         </p:txBody>
@@ -9842,7 +9842,7 @@
                 </a:solidFill>
                 <a:latin typeface="Arial"/>
               </a:rPr>
-              <a:t>the gap</a:t>
+              <a:t>score prediction</a:t>
             </a:r>
           </a:p>
         </p:txBody>
@@ -15522,13 +15522,13 @@
           <a:p>
             <a:pPr algn="l"/>
             <a:r>
-              <a:rPr sz="1200" b="1" i="0">
+              <a:rPr sz="1500" b="1" i="0">
                 <a:solidFill>
                   <a:srgbClr val="F47321"/>
                 </a:solidFill>
                 <a:latin typeface="Arial"/>
               </a:rPr>
-              <a:t>1.5 on Baylor · U-TAIL under 59.5</a:t>
+              <a:t>Auburn 33 – Baylor 27</a:t>
             </a:r>
           </a:p>
         </p:txBody>
@@ -15563,7 +15563,7 @@
                 </a:solidFill>
                 <a:latin typeface="Arial"/>
               </a:rPr>
-              <a:t>the gap</a:t>
+              <a:t>score prediction</a:t>
             </a:r>
           </a:p>
         </p:txBody>
@@ -18168,13 +18168,13 @@
           <a:p>
             <a:pPr algn="l"/>
             <a:r>
-              <a:rPr sz="1200" b="1" i="0">
+              <a:rPr sz="1500" b="1" i="0">
                 <a:solidFill>
                   <a:srgbClr val="F47321"/>
                 </a:solidFill>
                 <a:latin typeface="Arial"/>
               </a:rPr>
-              <a:t>1.5 to Clemson — quibble, not a play</a:t>
+              <a:t>LSU 30 – Clemson 21</a:t>
             </a:r>
           </a:p>
         </p:txBody>
@@ -18209,7 +18209,7 @@
                 </a:solidFill>
                 <a:latin typeface="Arial"/>
               </a:rPr>
-              <a:t>the gap</a:t>
+              <a:t>score prediction</a:t>
             </a:r>
           </a:p>
         </p:txBody>
@@ -20814,13 +20814,13 @@
           <a:p>
             <a:pPr algn="l"/>
             <a:r>
-              <a:rPr sz="1200" b="1" i="0">
+              <a:rPr sz="1300" b="1" i="0">
                 <a:solidFill>
                   <a:srgbClr val="F47321"/>
                 </a:solidFill>
                 <a:latin typeface="Arial"/>
               </a:rPr>
-              <a:t>machine = market — no gap</a:t>
+              <a:t>Ole Miss 31 – Louisville 25</a:t>
             </a:r>
           </a:p>
         </p:txBody>
@@ -20855,7 +20855,7 @@
                 </a:solidFill>
                 <a:latin typeface="Arial"/>
               </a:rPr>
-              <a:t>the gap</a:t>
+              <a:t>score prediction</a:t>
             </a:r>
           </a:p>
         </p:txBody>

</xml_diff>

<commit_message>
Pre-record pull: air-time lines (Sep 1, 3:10 PM CT)
Co-Authored-By: Claude Fable 5 <noreply@anthropic.com>
</commit_message>
<xml_diff>
--- a/decks/2026_Week1_Episode2.pptx
+++ b/decks/2026_Week1_Episode2.pptx
@@ -3463,7 +3463,7 @@
                 </a:solidFill>
                 <a:latin typeface="Arial"/>
               </a:rPr>
-              <a:t>Auburn –5.5   ·   –7 / –7</a:t>
+              <a:t>Auburn –5.5   ·   –7.5 / –7</a:t>
             </a:r>
           </a:p>
         </p:txBody>
@@ -3783,7 +3783,7 @@
                 </a:solidFill>
                 <a:latin typeface="Arial"/>
               </a:rPr>
-              <a:t>LSU –9   ·   –10.5 / –10.5</a:t>
+              <a:t>LSU –9   ·   –10 / –10</a:t>
             </a:r>
           </a:p>
         </p:txBody>
@@ -4103,7 +4103,7 @@
                 </a:solidFill>
                 <a:latin typeface="Arial"/>
               </a:rPr>
-              <a:t>Ole Miss –6.5   ·   –7 / –6.5</a:t>
+              <a:t>Ole Miss –6.5   ·   –7 / –7</a:t>
             </a:r>
           </a:p>
         </p:txBody>
@@ -4423,7 +4423,7 @@
                 </a:solidFill>
                 <a:latin typeface="Arial"/>
               </a:rPr>
-              <a:t>ND –21   ·   –20.5 / –20</a:t>
+              <a:t>ND –21   ·   –20.5 / –20.5</a:t>
             </a:r>
           </a:p>
         </p:txBody>
@@ -4813,7 +4813,7 @@
                 </a:solidFill>
                 <a:latin typeface="Arial"/>
               </a:rPr>
-              <a:t>Machine = ESPN 2026 preseason FPI + 2.5 HFA, empirical margin curve (σ 17.9, 2021–25 fit) · lines as of Aug 31 · model plays graded vs first-seen lines</a:t>
+              <a:t>Machine = ESPN 2026 preseason FPI + 2.5 HFA, empirical margin curve (σ 17.9, 2021–25 fit) · lines as of Sep 1 · model plays graded vs first-seen lines</a:t>
             </a:r>
           </a:p>
         </p:txBody>
@@ -7091,7 +7091,7 @@
                 </a:solidFill>
                 <a:latin typeface="Arial"/>
               </a:rPr>
-              <a:t>–20.5 / –20</a:t>
+              <a:t>–20.5 / –20.5</a:t>
             </a:r>
           </a:p>
         </p:txBody>
@@ -7126,7 +7126,7 @@
                 </a:solidFill>
                 <a:latin typeface="Arial"/>
               </a:rPr>
-              <a:t>market (DK / Bovada) · DK ND -1800 / Wisconsin +1000 · Bov ND -2500 / Wisconsin +1000</a:t>
+              <a:t>market (DK / Bovada) · DK ND -1650 / Wisconsin +950 · Bov ND -2500 / Wisconsin +1000</a:t>
             </a:r>
           </a:p>
         </p:txBody>
@@ -9772,7 +9772,7 @@
                 </a:solidFill>
                 <a:latin typeface="Arial"/>
               </a:rPr>
-              <a:t>market (DK / Bovada) · DK FSU +130 / SMU -155 · Bov FSU +145 / SMU -170</a:t>
+              <a:t>market (DK / Bovada) · DK FSU +136 / SMU -162 · Bov FSU +145 / SMU -170</a:t>
             </a:r>
           </a:p>
         </p:txBody>
@@ -11936,7 +11936,7 @@
                 </a:solidFill>
                 <a:latin typeface="Arial"/>
               </a:rPr>
-              <a:t>market –7 / –7</a:t>
+              <a:t>market –7.5 / –7</a:t>
             </a:r>
           </a:p>
         </p:txBody>
@@ -12221,7 +12221,7 @@
                 </a:solidFill>
                 <a:latin typeface="Arial"/>
               </a:rPr>
-              <a:t>market –10.5 / –10.5</a:t>
+              <a:t>market –10 / –10</a:t>
             </a:r>
           </a:p>
         </p:txBody>
@@ -12506,7 +12506,7 @@
                 </a:solidFill>
                 <a:latin typeface="Arial"/>
               </a:rPr>
-              <a:t>market –7 / –6.5</a:t>
+              <a:t>market –7 / –7</a:t>
             </a:r>
           </a:p>
         </p:txBody>
@@ -12791,7 +12791,7 @@
                 </a:solidFill>
                 <a:latin typeface="Arial"/>
               </a:rPr>
-              <a:t>market –20.5 / –20</a:t>
+              <a:t>market –20.5 / –20.5</a:t>
             </a:r>
           </a:p>
         </p:txBody>
@@ -13190,7 +13190,7 @@
                 </a:solidFill>
                 <a:latin typeface="Arial"/>
               </a:rPr>
-              <a:t>Coastal Carolina +21.5 at West Virginia · ML +1000</a:t>
+              <a:t>Coastal Carolina +21 at West Virginia · ML +950</a:t>
             </a:r>
           </a:p>
         </p:txBody>
@@ -15458,7 +15458,7 @@
                 </a:solidFill>
                 <a:latin typeface="Arial"/>
               </a:rPr>
-              <a:t>–7 / –7</a:t>
+              <a:t>–7.5 / –7</a:t>
             </a:r>
           </a:p>
         </p:txBody>
@@ -15493,7 +15493,7 @@
                 </a:solidFill>
                 <a:latin typeface="Arial"/>
               </a:rPr>
-              <a:t>market (DK / Bovada) · DK Auburn -298 / Baylor +240 · Bov Auburn -270 / Baylor +220</a:t>
+              <a:t>market (DK / Bovada) · DK Auburn -285 / Baylor +230 · Bov Auburn -270 / Baylor +220</a:t>
             </a:r>
           </a:p>
         </p:txBody>
@@ -15791,7 +15791,7 @@
                 </a:solidFill>
                 <a:latin typeface="Arial"/>
               </a:rPr>
-              <a:t>LINE MOVE  –6.5 → –7 · CLV -0.5</a:t>
+              <a:t>LINE MOVE  –6.5 → –7.5 · CLV -1</a:t>
             </a:r>
           </a:p>
         </p:txBody>
@@ -15826,7 +15826,7 @@
                 </a:solidFill>
                 <a:latin typeface="Arial"/>
               </a:rPr>
-              <a:t>Line movement: first-seen –6.5 (Aug 18) → now –7 · CLV -0.5</a:t>
+              <a:t>Line movement: first-seen –6.5 (Aug 18) → now –7.5 · CLV -1</a:t>
             </a:r>
           </a:p>
         </p:txBody>
@@ -18104,7 +18104,7 @@
                 </a:solidFill>
                 <a:latin typeface="Arial"/>
               </a:rPr>
-              <a:t>–10.5 / –10.5</a:t>
+              <a:t>–10 / –10</a:t>
             </a:r>
           </a:p>
         </p:txBody>
@@ -18139,7 +18139,7 @@
                 </a:solidFill>
                 <a:latin typeface="Arial"/>
               </a:rPr>
-              <a:t>market (DK / Bovada) · DK LSU -380 / Clemson +300 · Bov LSU -480 / Clemson +350</a:t>
+              <a:t>market (DK / Bovada) · DK LSU -375 / Clemson +295 · Bov LSU -480 / Clemson +350</a:t>
             </a:r>
           </a:p>
         </p:txBody>
@@ -18437,7 +18437,7 @@
                 </a:solidFill>
                 <a:latin typeface="Arial"/>
               </a:rPr>
-              <a:t>LINE MOVE  –10.5 → –10.5</a:t>
+              <a:t>LINE MOVE  –10.5 → –10 · CLV +0.5</a:t>
             </a:r>
           </a:p>
         </p:txBody>
@@ -18472,7 +18472,7 @@
                 </a:solidFill>
                 <a:latin typeface="Arial"/>
               </a:rPr>
-              <a:t>Line movement: first-seen –10.5 (Aug 18) → now –10.5 · opened –11.5 · CLV +0</a:t>
+              <a:t>Line movement: first-seen –10.5 (Aug 18) → now –10 · opened –11.5 · CLV +0.5</a:t>
             </a:r>
           </a:p>
         </p:txBody>
@@ -20750,7 +20750,7 @@
                 </a:solidFill>
                 <a:latin typeface="Arial"/>
               </a:rPr>
-              <a:t>–7 / –6.5</a:t>
+              <a:t>–7 / –7</a:t>
             </a:r>
           </a:p>
         </p:txBody>
@@ -20785,7 +20785,7 @@
                 </a:solidFill>
                 <a:latin typeface="Arial"/>
               </a:rPr>
-              <a:t>market (DK / Bovada) · DK Ole Miss -258 / Louisville +210 · Bov Ole Miss -270 / Louisville +220</a:t>
+              <a:t>market (DK / Bovada) · DK Ole Miss -265 / Louisville +215 · Bov Ole Miss -270 / Louisville +220</a:t>
             </a:r>
           </a:p>
         </p:txBody>

</xml_diff>

<commit_message>
Clemson-LSU: expanded slide talking points (bullets, honesty, keys)
Co-Authored-By: Claude Fable 5 <noreply@anthropic.com>
</commit_message>
<xml_diff>
--- a/decks/2026_Week1_Episode2.pptx
+++ b/decks/2026_Week1_Episode2.pptx
@@ -17569,7 +17569,7 @@
                 </a:solidFill>
                 <a:latin typeface="Arial"/>
               </a:rPr>
-              <a:t>Kiffin's first game at LSU — a CFP-or-bust construction unveiled at night in Death Valley</a:t>
+              <a:t>The biggest coaching debut of the season: Kiffin left a 13-win CFP team for this — first drive at night in Death Valley</a:t>
             </a:r>
           </a:p>
         </p:txBody>
@@ -17648,7 +17648,7 @@
                 </a:solidFill>
                 <a:latin typeface="Arial"/>
               </a:rPr>
-              <a:t>Dabo answering the worst season in 15 years with a first-year QB and a throwback OC</a:t>
+              <a:t>Dabo answers his worst season in 15 years with a throwback: Morris back as OC, first-year QB Vizzina — and Clemson opens UNRANKED vs No. 11</a:t>
             </a:r>
           </a:p>
         </p:txBody>
@@ -17727,7 +17727,7 @@
                 </a:solidFill>
                 <a:latin typeface="Arial"/>
               </a:rPr>
-              <a:t>LSU returns 21% of production with 44 portal adds — the most aggressive retool on the card; Clemson added 11</a:t>
+              <a:t>Opposite repair jobs: LSU rebuilt with 44 transfers (21% back), Clemson added just 11 (41% back) — Saturday tells us which was right</a:t>
             </a:r>
           </a:p>
         </p:txBody>
@@ -17806,7 +17806,7 @@
                 </a:solidFill>
                 <a:latin typeface="Arial"/>
               </a:rPr>
-              <a:t>Week 1 loser burns a playoff mulligan immediately — both fanbases know it</a:t>
+              <a:t>The market opened −11.5 and has walked to −10, toward the machine's −9 all week — and the loser burns a playoff mulligan</a:t>
             </a:r>
           </a:p>
         </p:txBody>
@@ -17885,7 +17885,7 @@
                 </a:solidFill>
                 <a:latin typeface="Arial"/>
               </a:rPr>
-              <a:t>The machine's −9.1 is a preseason guess about a team with a new head coach, new QB and new OC — and the same is true across the field. The market opened −11.5 and drifted to −10.5; the machine sits a point and a half friendlier to Clemson. Install-week variance says treat all of it gently.</a:t>
+              <a:t>The machine's −9.1 is a preseason guess about a program running its second system and second staff inside one calendar year — and Clemson's offense is just as new. Install-week variance says treat every number here gently; 30–21 is a margin on a market total, not a script.</a:t>
             </a:r>
           </a:p>
         </p:txBody>
@@ -18925,7 +18925,7 @@
                 </a:solidFill>
                 <a:latin typeface="Arial"/>
               </a:rPr>
-              <a:t>Let Allen's defense set the terms early</a:t>
+              <a:t>Let Allen's defense set the terms — the only unit on this field that never stopped being itself</a:t>
             </a:r>
           </a:p>
         </p:txBody>
@@ -19004,7 +19004,7 @@
                 </a:solidFill>
                 <a:latin typeface="Arial"/>
               </a:rPr>
-              <a:t>Give Vizzina pressure answers — quick game and screens</a:t>
+              <a:t>Give Vizzina his pressure answers BEFORE the snap: quick game and screens, no improvising against Baker</a:t>
             </a:r>
           </a:p>
         </p:txBody>
@@ -19083,7 +19083,7 @@
                 </a:solidFill>
                 <a:latin typeface="Arial"/>
               </a:rPr>
-              <a:t>Win explosives; don't trade field goals with LSU's skill talent</a:t>
+              <a:t>Win explosives — don't trade field goals with LSU's skill talent; the top-5 blue-chip roster has to cash as big plays</a:t>
             </a:r>
           </a:p>
         </p:txBody>
@@ -19162,7 +19162,7 @@
                 </a:solidFill>
                 <a:latin typeface="Arial"/>
               </a:rPr>
-              <a:t>Silence the crowd with third-down conversions</a:t>
+              <a:t>Silence the crowd on third down — remove Death Valley's 2.5 and the machine has this at only 6.6</a:t>
             </a:r>
           </a:p>
         </p:txBody>
@@ -19650,7 +19650,7 @@
                 </a:solidFill>
                 <a:latin typeface="Arial"/>
               </a:rPr>
-              <a:t>Protect Leavitt — the rebuilt OL is the bet of the season</a:t>
+              <a:t>Protect Leavitt — the portal-built OL on a short runway is the bet of the entire season</a:t>
             </a:r>
           </a:p>
         </p:txBody>
@@ -19729,7 +19729,7 @@
                 </a:solidFill>
                 <a:latin typeface="Arial"/>
               </a:rPr>
-              <a:t>Tempo early: make Allen's defense align fast, then strike</a:t>
+              <a:t>Tempo early: force Allen's 4-2-5 to line up plain before the disguises load</a:t>
             </a:r>
           </a:p>
         </p:txBody>
@@ -19808,7 +19808,7 @@
                 </a:solidFill>
                 <a:latin typeface="Arial"/>
               </a:rPr>
-              <a:t>Let Baker hunt with the pressure package on obvious downs</a:t>
+              <a:t>Let Baker hunt — SP+'s projected No. 2 defense against a first-career-start QB</a:t>
             </a:r>
           </a:p>
         </p:txBody>
@@ -19887,7 +19887,7 @@
                 </a:solidFill>
                 <a:latin typeface="Arial"/>
               </a:rPr>
-              <a:t>Finish drives — red-zone scripts vs a blue-chip front</a:t>
+              <a:t>Finish in the red zone: settling for field goals keeps an unranked underdog alive all night</a:t>
             </a:r>
           </a:p>
         </p:txBody>

</xml_diff>

<commit_message>
Expanded slide talking points for all games and team slides
Co-Authored-By: Claude Fable 5 <noreply@anthropic.com>
</commit_message>
<xml_diff>
--- a/decks/2026_Week1_Episode2.pptx
+++ b/decks/2026_Week1_Episode2.pptx
@@ -5266,7 +5266,7 @@
                 </a:solidFill>
                 <a:latin typeface="Arial"/>
               </a:rPr>
-              <a:t>Ride the run game and keep Chambliss on the sideline</a:t>
+              <a:t>Ride the run game — the RB room is the roster's sneaky strength, and every carry keeps Chambliss on the sideline</a:t>
             </a:r>
           </a:p>
         </p:txBody>
@@ -5345,7 +5345,7 @@
                 </a:solidFill>
                 <a:latin typeface="Arial"/>
               </a:rPr>
-              <a:t>No coverage busts — the season-long bug can't show up here</a:t>
+              <a:t>No coverage busts: top-20 havoc with bottom-40 explosives allowed is the Brohm tradeoff — one bust loses this game</a:t>
             </a:r>
           </a:p>
         </p:txBody>
@@ -5424,7 +5424,7 @@
                 </a:solidFill>
                 <a:latin typeface="Arial"/>
               </a:rPr>
-              <a:t>Pressure with the edges, not blitz-and-bust gambles</a:t>
+              <a:t>Pressure with the edges vs a rebuilt Ole Miss pass-pro — the one matchup the underdog clearly wins</a:t>
             </a:r>
           </a:p>
         </p:txBody>
@@ -5503,7 +5503,7 @@
                 </a:solidFill>
                 <a:latin typeface="Arial"/>
               </a:rPr>
-              <a:t>Keep Kienholz's menu short and make an early lead real</a:t>
+              <a:t>Keep Kienholz's menu short — Brohm's system has made a top-25 offense of every QB; let it work before asking for heroes</a:t>
             </a:r>
           </a:p>
         </p:txBody>
@@ -5991,7 +5991,7 @@
                 </a:solidFill>
                 <a:latin typeface="Arial"/>
               </a:rPr>
-              <a:t>Let Chambliss escape — the off-script plays are the edge</a:t>
+              <a:t>Let Chambliss escape — statistically the nation's best at turning dead plays into first downs</a:t>
             </a:r>
           </a:p>
         </p:txBody>
@@ -6070,7 +6070,7 @@
                 </a:solidFill>
                 <a:latin typeface="Arial"/>
               </a:rPr>
-              <a:t>Interior line vs Louisville's backfield: end the run game early</a:t>
+              <a:t>The interior line ends Louisville's run game early — force the least-proven Brohm QB to win it himself</a:t>
             </a:r>
           </a:p>
         </p:txBody>
@@ -6149,7 +6149,7 @@
                 </a:solidFill>
                 <a:latin typeface="Arial"/>
               </a:rPr>
-              <a:t>Tempo the Brohm defense into simple, static looks</a:t>
+              <a:t>Tempo the Brohm defense into simple, static looks — no disguise time, no gambling looks</a:t>
             </a:r>
           </a:p>
         </p:txBody>
@@ -6228,7 +6228,7 @@
                 </a:solidFill>
                 <a:latin typeface="Arial"/>
               </a:rPr>
-              <a:t>Win field position all night on a neutral floor</a:t>
+              <a:t>Win field position all night — on a neutral floor against a new QB, the long field is a weapon</a:t>
             </a:r>
           </a:p>
         </p:txBody>
@@ -6556,7 +6556,7 @@
                 </a:solidFill>
                 <a:latin typeface="Arial"/>
               </a:rPr>
-              <a:t>The revenge tour begins — 'Leave No Doubt' opens at Lambeau Field</a:t>
+              <a:t>The revenge tour begins: 'Leave No Doubt' was born from the selection-show snub — Freeman rewatches the pain on purpose</a:t>
             </a:r>
           </a:p>
         </p:txBody>
@@ -6635,7 +6635,7 @@
                 </a:solidFill>
                 <a:latin typeface="Arial"/>
               </a:rPr>
-              <a:t>ND is the card's continuity outlier: Carr in year two, 51% of production back, just 7 portal adds</a:t>
+              <a:t>ND is the card's continuity outlier — Carr in year two, 51% of production back, just 7 portal adds — in a week full of reboots</a:t>
             </a:r>
           </a:p>
         </p:txBody>
@@ -6714,7 +6714,7 @@
                 </a:solidFill>
                 <a:latin typeface="Arial"/>
               </a:rPr>
-              <a:t>Fickell's survival season starts as a 20-point dog, with a new QB again (Joseph, 31% back)</a:t>
+              <a:t>Fickell's survival season: a public vote of confidence, the Air Raid detour dead, and a G5 dual-threat QB making the B1G jump as a 20-point dog</a:t>
             </a:r>
           </a:p>
         </p:txBody>
@@ -6793,7 +6793,7 @@
                 </a:solidFill>
                 <a:latin typeface="Arial"/>
               </a:rPr>
-              <a:t>A No. 1-seed résumé game for the Irish; a cover is Wisconsin's moral win</a:t>
+              <a:t>No. 4 ND plays for a top-seed résumé; Wisconsin's 3-3-5 — top-25 two straight years with zero offensive help — plays for a moral cover</a:t>
             </a:r>
           </a:p>
         </p:txBody>
@@ -6872,7 +6872,7 @@
                 </a:solidFill>
                 <a:latin typeface="Arial"/>
               </a:rPr>
-              <a:t>Housekeeping: our ledger's July first-seen on this game is a known CFBD sides-flip data error, so the honest movement read is the opener — Bovada hung −16.5 and the market walked it to −20.5, four points toward the Irish. Machine −21.1, market −20.5: nothing to do but watch.</a:t>
+              <a:t>Housekeeping: our ledger's July first-seen here is a known CFBD sides-flip error — the honest movement read is the opener, −16.5 walked to −20.5, four points toward the Irish. Machine −21.1, market −20.5: agreement, and spreads this size sit in the favorite-longshot zone anyway. Watch, don't touch.</a:t>
             </a:r>
           </a:p>
         </p:txBody>
@@ -7912,7 +7912,7 @@
                 </a:solidFill>
                 <a:latin typeface="Arial"/>
               </a:rPr>
-              <a:t>Shorten the game: long drives, no clock stoppages, no gifts</a:t>
+              <a:t>Shorten the game: long drives, clock runs, zero gifts — fewer possessions is the underdog's only math</a:t>
             </a:r>
           </a:p>
         </p:txBody>
@@ -7991,7 +7991,7 @@
                 </a:solidFill>
                 <a:latin typeface="Arial"/>
               </a:rPr>
-              <a:t>Find counters vs a tite front built to erase the run-first pivot</a:t>
+              <a:t>Find counters vs the tite front built to erase the run-first pivot — the league's most veteran OL has to earn it</a:t>
             </a:r>
           </a:p>
         </p:txBody>
@@ -8070,7 +8070,7 @@
                 </a:solidFill>
                 <a:latin typeface="Arial"/>
               </a:rPr>
-              <a:t>Joseph's legs on third-and-medium — the one chain-mover that travels</a:t>
+              <a:t>Joseph's legs on third-and-medium — the one chain-mover that travels up from the G5</a:t>
             </a:r>
           </a:p>
         </p:txBody>
@@ -8149,7 +8149,7 @@
                 </a:solidFill>
                 <a:latin typeface="Arial"/>
               </a:rPr>
-              <a:t>Force Carr to beat the 3-3-5 from the pocket</a:t>
+              <a:t>Force Carr to beat the 3-3-5 from the pocket — this defense is genuinely good enough to keep it inside 20</a:t>
             </a:r>
           </a:p>
         </p:txBody>
@@ -8637,7 +8637,7 @@
                 </a:solidFill>
                 <a:latin typeface="Arial"/>
               </a:rPr>
-              <a:t>Post-Love backfield: prove the duo/counter identity early</a:t>
+              <a:t>Prove the post-Love duo/counter identity early — the gap-scheme run game sets up everything else</a:t>
             </a:r>
           </a:p>
         </p:txBody>
@@ -8716,7 +8716,7 @@
                 </a:solidFill>
                 <a:latin typeface="Arial"/>
               </a:rPr>
-              <a:t>Carr in rhythm — play-action on schedule, nothing forced</a:t>
+              <a:t>Carr in rhythm: play-action on schedule, nothing forced — his year-two leap is the top 10's likeliest QB jump</a:t>
             </a:r>
           </a:p>
         </p:txBody>
@@ -8795,7 +8795,7 @@
                 </a:solidFill>
                 <a:latin typeface="Arial"/>
               </a:rPr>
-              <a:t>Erase explosives; make Wisconsin play 12-play drives</a:t>
+              <a:t>Erase explosives and make Wisconsin drive 12 plays — bend-don't-break with elite tackling wins by attrition</a:t>
             </a:r>
           </a:p>
         </p:txBody>
@@ -8874,7 +8874,7 @@
                 </a:solidFill>
                 <a:latin typeface="Arial"/>
               </a:rPr>
-              <a:t>'Leave No Doubt' means no scoreboard mercy — bury it early</a:t>
+              <a:t>'Leave No Doubt' means no scoreboard mercy — style points are seed points in a week-one résumé game</a:t>
             </a:r>
           </a:p>
         </p:txBody>
@@ -9202,7 +9202,7 @@
                 </a:solidFill>
                 <a:latin typeface="Arial"/>
               </a:rPr>
-              <a:t>Monday night, alone on the calendar — the week's last word</a:t>
+              <a:t>Monday night, alone on the calendar — the whole sport watches the week's last word</a:t>
             </a:r>
           </a:p>
         </p:txBody>
@@ -9281,7 +9281,7 @@
                 </a:solidFill>
                 <a:latin typeface="Arial"/>
               </a:rPr>
-              <a:t>FSU's 36-month whiplash (CFP → 2–10 → reset) meets SMU's post-CFP expectations</a:t>
+              <a:t>No program swung harder in 36 months than FSU (CFP → 2–10 → rebound) — now it hosts SMU's post-CFP expectations and a No. 19 ranking</a:t>
             </a:r>
           </a:p>
         </p:txBody>
@@ -9360,7 +9360,7 @@
                 </a:solidFill>
                 <a:latin typeface="Arial"/>
               </a:rPr>
-              <a:t>SMU kept the roster (57% back) but lost both coordinators; FSU kept Norvell but reloads via portal again</a:t>
+              <a:t>SMU kept the roster (57% back, 15 adds) but lost BOTH coordinators to committee troikas; FSU kept Norvell but rents portal QBs a third time</a:t>
             </a:r>
           </a:p>
         </p:txBody>
@@ -9439,7 +9439,7 @@
                 </a:solidFill>
                 <a:latin typeface="Arial"/>
               </a:rPr>
-              <a:t>RED ALERT: the machine takes the home dog outright — FSU 52%, market 42%</a:t>
+              <a:t>RED ALERT: machine takes the home dog outright — FSU 52% vs market 42%; strip home field and it actually favors SMU by 1.8</a:t>
             </a:r>
           </a:p>
         </p:txBody>
@@ -9518,7 +9518,7 @@
                 </a:solidFill>
                 <a:latin typeface="Arial"/>
               </a:rPr>
-              <a:t>Respect the backtest: RED alerts hit 49.7% ATS across 2023–25 — below break-even. The flag is a research shortlist, not a pick. And FSU's 36-month whiplash (CFP → 2–10 → reset) makes its preseason prior the least trustworthy number on this card.</a:t>
+              <a:t>Respect the backtest: RED alerts hit 49.7% ATS across 2023–25 — the flag is a research shortlist, not a pick. The entire machine case is the 2.5-point Monday-night home bump — neutralize the Doak and it likes SMU. And FSU's whiplash makes its prior the least trustworthy number on this card.</a:t>
             </a:r>
           </a:p>
         </p:txBody>
@@ -10558,7 +10558,7 @@
                 </a:solidFill>
                 <a:latin typeface="Arial"/>
               </a:rPr>
-              <a:t>Prove the troika can call it: tempo and spacing from drive one</a:t>
+              <a:t>Prove the troika can call it — tempo and spacing from drive one, no committee hesitation on fourth downs</a:t>
             </a:r>
           </a:p>
         </p:txBody>
@@ -10637,7 +10637,7 @@
                 </a:solidFill>
                 <a:latin typeface="Arial"/>
               </a:rPr>
-              <a:t>Protect the new quarterback against a rebuilt FSU front</a:t>
+              <a:t>Protect the new quarterback from FSU's top-10 portal front — line play is the one place SMU is a tier below</a:t>
             </a:r>
           </a:p>
         </p:txBody>
@@ -10716,7 +10716,7 @@
                 </a:solidFill>
                 <a:latin typeface="Arial"/>
               </a:rPr>
-              <a:t>Explosives, not field goals — White's 3-3-5 bends on purpose</a:t>
+              <a:t>Explosives, not field goals: White's 3-3-5 bends on purpose — long drives are the trap, chunk plays are the answer</a:t>
             </a:r>
           </a:p>
         </p:txBody>
@@ -10795,7 +10795,7 @@
                 </a:solidFill>
                 <a:latin typeface="Arial"/>
               </a:rPr>
-              <a:t>Win the takeaway ledger: the gambling profile has to cash</a:t>
+              <a:t>Win the takeaway ledger — the gambling back seven has to cash on the road, Monday night</a:t>
             </a:r>
           </a:p>
         </p:txBody>
@@ -11283,7 +11283,7 @@
                 </a:solidFill>
                 <a:latin typeface="Arial"/>
               </a:rPr>
-              <a:t>Run it with the portal front — make it physical early</a:t>
+              <a:t>Run it with the portal front — make the game physical exactly where the trench classes graded top-10</a:t>
             </a:r>
           </a:p>
         </p:txBody>
@@ -11362,7 +11362,7 @@
                 </a:solidFill>
                 <a:latin typeface="Arial"/>
               </a:rPr>
-              <a:t>Quarterback run as the cheat code in Norvell's heavier hand</a:t>
+              <a:t>Quarterback run is the cheat code in Norvell's heavier-hand offense — the extra hat SMU's smaller front must answer</a:t>
             </a:r>
           </a:p>
         </p:txBody>
@@ -11441,7 +11441,7 @@
                 </a:solidFill>
                 <a:latin typeface="Arial"/>
               </a:rPr>
-              <a:t>No boom-bust: field position over hero ball</a:t>
+              <a:t>No boom-bust: field position over hero ball — the whiplash program cannot beat itself Monday</a:t>
             </a:r>
           </a:p>
         </p:txBody>
@@ -11520,7 +11520,7 @@
                 </a:solidFill>
                 <a:latin typeface="Arial"/>
               </a:rPr>
-              <a:t>Start fast and let the Monday-night Doak crowd matter</a:t>
+              <a:t>Start fast and make the Doak matter — the machine's whole case for FSU is worth 2.5 points of Monday night</a:t>
             </a:r>
           </a:p>
         </p:txBody>
@@ -14923,7 +14923,7 @@
                 </a:solidFill>
                 <a:latin typeface="Arial"/>
               </a:rPr>
-              <a:t>Two rebooted programs on a neutral floor: Golesh's Auburn debut vs the biggest QB get in Baylor history</a:t>
+              <a:t>Two rebooted programs, one neutral floor: Golesh's Auburn debut (USF's No. 2 total offense travels with him) vs Lagway's Baylor debut</a:t>
             </a:r>
           </a:p>
         </p:txBody>
@@ -15002,7 +15002,7 @@
                 </a:solidFill>
                 <a:latin typeface="Arial"/>
               </a:rPr>
-              <a:t>The card's starkest contrast — Auburn returns 14% of production (39 portal adds), Baylor returns 60%</a:t>
+              <a:t>The starkest contrast on the card: Auburn returns 14% of its offense and rebuilt with 39 transfers — Baylor returns 60%, the most continuity here</a:t>
             </a:r>
           </a:p>
         </p:txBody>
@@ -15081,7 +15081,7 @@
                 </a:solidFill>
                 <a:latin typeface="Arial"/>
               </a:rPr>
-              <a:t>Lagway's health is the single biggest variable in the Big 12 season</a:t>
+              <a:t>Lagway's health (shoulder and leg in 2025) is the Big 12 season's biggest single variable — Auburn's top-10 DL is the first test</a:t>
             </a:r>
           </a:p>
         </p:txBody>
@@ -15160,7 +15160,7 @@
                 </a:solidFill>
                 <a:latin typeface="Arial"/>
               </a:rPr>
-              <a:t>The 59.5 total is top-decile — five years of closing lines say that class of game goes UNDER 55% of the time</a:t>
+              <a:t>The 59.5 total is top-decile — five years of closing lines say that class goes UNDER 55% of the time, and two year-one offenses in a dome only helps</a:t>
             </a:r>
           </a:p>
         </p:txBody>
@@ -15239,7 +15239,7 @@
                 </a:solidFill>
                 <a:latin typeface="Arial"/>
               </a:rPr>
-              <a:t>Both sidelines are running year-one installs the preseason numbers can't see — and the machine's prior hasn't ingested a single 2026 snap yet (first in-season FPI refresh lands Tuesday). Machine −5.5 vs market −7 is a quibble, not a position.</a:t>
+              <a:t>Both sidelines are running year-one installs the preseason numbers can't see — the machine's prior hasn't ingested a single 2026 snap. Auburn's edge is a talent prior; Baylor's counter is cohesion. Machine −5.5 vs market −7.5: a quibble, not a position.</a:t>
             </a:r>
           </a:p>
         </p:txBody>
@@ -16279,7 +16279,7 @@
                 </a:solidFill>
                 <a:latin typeface="Arial"/>
               </a:rPr>
-              <a:t>Keep Lagway upright and healthy — everything else is decoration</a:t>
+              <a:t>Keep Lagway upright — his 2025 injury file is the season's whole risk profile; everything else is decoration</a:t>
             </a:r>
           </a:p>
         </p:txBody>
@@ -16358,7 +16358,7 @@
                 </a:solidFill>
                 <a:latin typeface="Arial"/>
               </a:rPr>
-              <a:t>Beat the sim pressures on early downs; don't let Durkin tee off</a:t>
+              <a:t>Attack the rebuilt secondary: four transfer corners arrived — Auburn's front returned, the back end didn't</a:t>
             </a:r>
           </a:p>
         </p:txBody>
@@ -16437,7 +16437,7 @@
                 </a:solidFill>
                 <a:latin typeface="Arial"/>
               </a:rPr>
-              <a:t>Steal a possession with tempo of your own</a:t>
+              <a:t>Steal a possession with tempo — a halftime double-up covers the whole spread by itself</a:t>
             </a:r>
           </a:p>
         </p:txBody>
@@ -16516,7 +16516,7 @@
                 </a:solidFill>
                 <a:latin typeface="Arial"/>
               </a:rPr>
-              <a:t>Make Auburn's first-year offense play from behind</a:t>
+              <a:t>Make the install-week offense chase: an early lead forces a unit that's never played together to hurry</a:t>
             </a:r>
           </a:p>
         </p:txBody>
@@ -17004,7 +17004,7 @@
                 </a:solidFill>
                 <a:latin typeface="Arial"/>
               </a:rPr>
-              <a:t>Lean on the defense that didn't change</a:t>
+              <a:t>Lean on the defense that didn't change — 27 of the 39 transfers went to offense; Durkin's side kept its spine</a:t>
             </a:r>
           </a:p>
         </p:txBody>
@@ -17083,7 +17083,7 @@
                 </a:solidFill>
                 <a:latin typeface="Arial"/>
               </a:rPr>
-              <a:t>Tempo without turnovers — install-week ball security</a:t>
+              <a:t>Tempo without turnovers: speed multiplies mistakes in week one of an install — take the give, live with punts</a:t>
             </a:r>
           </a:p>
         </p:txBody>
@@ -17162,7 +17162,7 @@
                 </a:solidFill>
                 <a:latin typeface="Arial"/>
               </a:rPr>
-              <a:t>Feed the tight ends where Golesh's system lives</a:t>
+              <a:t>Feed the tight ends where Golesh's 12-personnel system lives</a:t>
             </a:r>
           </a:p>
         </p:txBody>
@@ -17241,7 +17241,7 @@
                 </a:solidFill>
                 <a:latin typeface="Arial"/>
               </a:rPr>
-              <a:t>Let the defensive line end drives on third down</a:t>
+              <a:t>Win the line with top-10 DL talent — Lagway under duress is the whole ballgame</a:t>
             </a:r>
           </a:p>
         </p:txBody>
@@ -20215,7 +20215,7 @@
                 </a:solidFill>
                 <a:latin typeface="Arial"/>
               </a:rPr>
-              <a:t>Golding's first game as the head man — keeping a 13-win CFP program's identity after Kiffin left with it</a:t>
+              <a:t>Golding's first game as the head man — can a promoted DC keep a 13-win CFP program's identity after Kiffin took its brain to Baton Rouge?</a:t>
             </a:r>
           </a:p>
         </p:txBody>
@@ -20294,7 +20294,7 @@
                 </a:solidFill>
                 <a:latin typeface="Arial"/>
               </a:rPr>
-              <a:t>Chambliss is the rare continuity star (50% of production back); Brohm counters with his third new QB1 in three years</a:t>
+              <a:t>Chambliss chose Oxford over following Kiffin — the rarest continuity win (50% back); Brohm counters with his third new QB1 in three years</a:t>
             </a:r>
           </a:p>
         </p:txBody>
@@ -20373,7 +20373,7 @@
                 </a:solidFill>
                 <a:latin typeface="Arial"/>
               </a:rPr>
-              <a:t>Sunday night in Nashville — neutral on paper, Ole Miss crowd in practice</a:t>
+              <a:t>Ranked vs ranked, Sunday night in Nashville: #24 Louisville, #9 Ole Miss — neutral on paper, an Ole Miss crowd in practice</a:t>
             </a:r>
           </a:p>
         </p:txBody>
@@ -20452,7 +20452,7 @@
                 </a:solidFill>
                 <a:latin typeface="Arial"/>
               </a:rPr>
-              <a:t>Both need this one: Louisville's easiest big-name scalp; Ole Miss defending the CFP-program label</a:t>
+              <a:t>SP+ projects Louisville favored in every game AFTER this one — win here and the huge ACC script is live; Ole Miss defends the CFP label</a:t>
             </a:r>
           </a:p>
         </p:txBody>
@@ -20531,7 +20531,7 @@
                 </a:solidFill>
                 <a:latin typeface="Arial"/>
               </a:rPr>
-              <a:t>The market opened −8.5 and walked to −6.5/−7 — it has come to the machine's −6.5. That's agreement, not edge. And nothing in a preseason prior prices a first-year head coach's game management on a Sunday neutral floor.</a:t>
+              <a:t>The market opened −8.5 and walked to −7 — it has come to the machine's −6.5. That's agreement, not edge. And nothing in a preseason prior prices a first-year head coach's clock-and-timeout management on a Sunday neutral floor.</a:t>
             </a:r>
           </a:p>
         </p:txBody>

</xml_diff>

<commit_message>
Live correction: Kevin Jennings RETURNS at SMU (was wrongly 'post-Jennings')
Co-Authored-By: Claude Fable 5 <noreply@anthropic.com>
</commit_message>
<xml_diff>
--- a/decks/2026_Week1_Episode2.pptx
+++ b/decks/2026_Week1_Episode2.pptx
@@ -9360,7 +9360,7 @@
                 </a:solidFill>
                 <a:latin typeface="Arial"/>
               </a:rPr>
-              <a:t>SMU kept the roster (57% back, 15 adds) but lost BOTH coordinators to committee troikas; FSU kept Norvell but rents portal QBs a third time</a:t>
+              <a:t>SMU kept the roster AND Jennings (57% back) but lost BOTH coordinators to troikas; FSU kept Norvell but rents portal QBs a third time</a:t>
             </a:r>
           </a:p>
         </p:txBody>
@@ -10409,7 +10409,7 @@
                 </a:solidFill>
                 <a:latin typeface="Arial"/>
               </a:rPr>
-              <a:t>NEW — post-Jennings; the system made 3 straight top-25 offenses with 3 QBs</a:t>
+              <a:t>RETURNS — Kevin Jennings; the system's made 3 straight top-25 offenses</a:t>
             </a:r>
           </a:p>
         </p:txBody>
@@ -10637,7 +10637,7 @@
                 </a:solidFill>
                 <a:latin typeface="Arial"/>
               </a:rPr>
-              <a:t>Protect the new quarterback from FSU's top-10 portal front — line play is the one place SMU is a tier below</a:t>
+              <a:t>Protect Jennings from FSU's top-10 portal front — line play is the one place SMU is a tier below</a:t>
             </a:r>
           </a:p>
         </p:txBody>

</xml_diff>